<commit_message>
Complete topic 5 report, connected bagging example and submission package
</commit_message>
<xml_diff>
--- a/De_5_Ensemble_Learning.pptx
+++ b/De_5_Ensemble_Learning.pptx
@@ -527,7 +527,7 @@
           <a:lstStyle/>
           <a:p>
             <a:r>
-              <a:t>Mở đầu: Một cây quyết định có thể thay đổi đáng kể khi dữ liệu huấn luyện thay đổi. Ensemble Learning kết hợp nhiều mô hình để giảm tác động của những sai lệch riêng. Bài này giới thiệu các họ phương pháp, sau đó đi sâu vào bootstrap và hard voting qua Bagging tự triển khai. Mã cây cơ sở dùng scikit-learn; phần lấy mẫu và tổng hợp phiếu do nhóm tự viết. Trước khi nộp, điền tên thành viên và lớp trên trang bìa. Gợi ý thời lượng phần chính khoảng 15–20 phút; hai trang cuối là phụ lục.</a:t>
+              <a:t>Mở đầu: Một cây quyết định có thể thay đổi đáng kể khi dữ liệu huấn luyện thay đổi. Ensemble Learning kết hợp nhiều mô hình để giảm tác động của những sai lệch riêng. Bài này giới thiệu các họ phương pháp, sau đó đi sâu vào bootstrap và hard voting qua Bagging tự triển khai. Mã cây cơ sở dùng scikit-learn; phần lấy mẫu và tổng hợp phiếu do nhóm tự viết. Thông tin thành viên và giảng viên được lấy thống nhất từ report/group_info.json. Gợi ý thời lượng phần chính khoảng 15–20 phút; hai trang cuối là phụ lục.</a:t>
             </a:r>
           </a:p>
         </p:txBody>
@@ -597,7 +597,7 @@
           <a:lstStyle/>
           <a:p>
             <a:r>
-              <a:t>AdaBoost là ví dụ để giải thích Boosting chứ chưa được triển khai trong mã thực nghiệm này. Nhãn và dự đoán trong công thức cập nhật cổ điển được mã hóa âm một và dương một. Sai số epsilon là tổng trọng số của các mẫu sai, không nhất thiết là tỷ lệ đếm mẫu. Nếu epsilon bằng 0,2, trọng số mô hình alpha bằng một nửa log tự nhiên của bốn, khoảng 0,693. Nhóm sai nhân hai, nhóm đúng nhân một phần hai; chuẩn hóa xong tổng trọng số nhóm sai tăng từ 0,2 lên 0,5. Gradient Boosting lại xây mô hình theo hướng giảm loss, thường khớp gradient âm; không mô tả mọi Boosting bằng duy nhất cập nhật AdaBoost này.</a:t>
+              <a:t>Đây là tổng quan để phân biệt Boosting với Bagging; phần chính không cần đi sâu công thức. AdaBoost chưa được triển khai trong mã thực nghiệm này. Số 20%→50% là ví dụ cập nhật trọng số, không phải accuracy hay phần trăm mẫu bị thay nhãn. Nếu được hỏi phép tính: với sai số có trọng số ε=0,2, α=½ln((1−ε)/ε)=0,693; nhóm sai nhân exp(α)=2, nhóm đúng nhân exp(−α)=0,5; sau chuẩn hóa, khối lượng trọng số nhóm sai là 0,2×2/(0,2×2+0,8×0,5)=0,5. Nhãn trong cập nhật cổ điển mã hóa −1,+1. Gradient Boosting giảm loss qua chuỗi mô hình, không dùng nguyên xi quy tắc AdaBoost này. Có thể nói ngắn slide 10–11 để dành thời gian cho Bagging tự triển khai.</a:t>
             </a:r>
           </a:p>
         </p:txBody>
@@ -1507,7 +1507,7 @@
           <a:lstStyle/>
           <a:p>
             <a:r>
-              <a:t>Mở terminal tại thư mục kho, dùng Python đã cài requirements.txt. Trên Windows có thể dùng py thay python. Thêm --repeats 1 --output-dir outputs/quick để demo nhanh vào thư mục riêng; khi đó summary chỉ có một lần chạy và SD là null, không phải 0. Lệnh không có tham số chạy 10 seed từ 42 đến 51. results.json có seed tham chiếu, OOB, ví dụ bất đồng và tổng hợp nhiều lần chạy; report.md giải thích kết quả. metrics.csv và predictions.csv thuộc seed tham chiếu, repeated_metrics.csv chứa từng seed, summary_metrics.csv chứa mean và SD. Mỗi lần chạy ghi đè các tệp cùng tên trong output-dir; outputs/quick giữ riêng kết quả demo và bảo toàn kết quả 10 seed trong outputs. Các slide này được tạo từ kết quả đầy đủ 10 seed, không được suy ra bảng đó từ demo một seed.</a:t>
+              <a:t>Mở terminal tại thư mục kho, dùng Python đã cài requirements.txt; trong cloud có thể thay python bằng .venv/bin/python. Chạy ví dụ nhỏ trước để thấy ba ngưỡng 2,5;3;2,5 và hai phiếu ác thắng một phiếu lành ở x=2,8. Sau đó chạy mô hình thật với --repeats 1 --output-dir outputs/quick. Demo một seed không tạo SD bằng 0; SD không xác định nên lưu null. Lệnh python de_5_ensemble_learning.py không có tham số chạy đủ 10 seed 42–51 vào outputs/. results.json lưu cấu hình, OOB, trace và số liệu; report.md giải thích thí nghiệm. Báo cáo bài viết hoàn chỉnh nằm ở report/Bao_cao_De_5_Ensemble_Learning.docx và PDF cùng tên, khác PDF slide ở thư mục gốc. Mỗi lần chạy thay thế các tệp cùng tên trong output-dir; thư mục quick giữ riêng demo. Các bảng nhiều seed trên slide lấy từ chạy đầy đủ, không suy từ demo một seed. Chuẩn bị sẵn output làm phương án dự phòng nếu buổi trình bày không chạy được máy.</a:t>
             </a:r>
           </a:p>
         </p:txBody>
@@ -1577,7 +1577,7 @@
           <a:lstStyle/>
           <a:p>
             <a:r>
-              <a:t>Kết lại ba ý. Một: hiệu quả ensemble đến từ cả chất lượng mô hình cơ sở lẫn sự đa dạng. Hai: Bagging gồm lấy mẫu có hoàn lại, học độc lập và tổng hợp; mã còn có OOB đúng theo các cây chưa thấy mẫu. Ba: seed tham chiếu đạt 95,10% accuracy và vẫn bỏ sót bốn ca ác tính; qua 10 holdout, accuracy trung bình của Bagging khoảng 94,76% với SD mẫu 1,59 điểm phần trăm. Các holdout có giao nhau nên không suy ra độ tin cậy độc lập hoặc hiệu quả lâm sàng. Nếu nhóm ba người, có thể chia trang 1–9, 10–15 và 16–24; đây chỉ là gợi ý, không phải phân công đã xác nhận. Hai trang cuối là phụ lục hỏi đáp và phép tính chỉ số.</a:t>
+              <a:t>Kết lại ba ý. Một: hiệu quả ensemble đến từ cả chất lượng mô hình cơ sở lẫn sự đa dạng. Hai: Bagging gồm lấy mẫu có hoàn lại, học độc lập và tổng hợp; ví dụ nhỏ đã nối đủ dữ liệu, ba bootstrap, ba cây và phiếu. Ba: seed tham chiếu đạt 95,10% accuracy và vẫn bỏ sót bốn ca ác tính; qua 10 holdout, accuracy trung bình của Bagging khoảng 94,76%, SD mẫu 1,59 điểm phần trăm. Chưa suy ra hiệu quả lâm sàng hoặc một phương pháp luôn thắng. Gợi ý tập luyện hai người: Nguyễn Nghĩa Hiếu trình bày trang 1–11, Trần Quốc Bảo trình bày trang 12–24; chuyển lời ở trang 12 từ ví dụ nhỏ sang bài toán thật. Đây là phương án chuẩn bị, không phải xác nhận lịch sử đóng góp. Cả hai cần hiểu code và sẵn sàng trả lời. Hai trang cuối dùng khi hỏi đáp.</a:t>
             </a:r>
           </a:p>
         </p:txBody>
@@ -1927,7 +1927,7 @@
           <a:lstStyle/>
           <a:p>
             <a:r>
-              <a:t>Công thức này giải thích trực giác giảm phương sai khi lấy trung bình các dự đoán số. Giả thiết các mô hình có phương sai như nhau σ bình phương và tương quan cặp chung rho. Với 51 mô hình, rho bằng 0,2 cho phương sai trung bình khoảng 0,216 lần phương sai riêng, còn rho bằng 0,8 chỉ giảm xuống khoảng 0,804. Đây không phải công thức trực tiếp của tỷ lệ lỗi phân lớp. Với hard voting, hiệu quả còn phụ thuộc mô hình cơ sở và cấu trúc lỗi. Không thể nói ensemble luôn tốt hơn.</a:t>
+              <a:t>Phần chính chỉ cần hiểu rằng cây quyết định có thể thay đổi khi dữ liệu train đổi; lấy nhiều bootstrap và tổng hợp giúp giảm dao động khi các cây không mắc lỗi quá giống nhau. Công thức bổ sung nếu được hỏi: Var(trung bình) = σ²[ρ + (1−ρ)/B], với B là số mô hình, σ² là phương sai chung, ρ là tương quan cặp chung. Với B=51, ρ=0,2 cho khoảng 0,216σ²; ρ=0,8 cho khoảng 0,804σ². Công thức áp dụng cho trung bình dự đoán số dưới các giả thiết trên, không phải công thức trực tiếp của lỗi hard voting. Không cần chứng minh công thức trong phần thuyết trình chính và không kết luận ensemble luôn tốt hơn.</a:t>
             </a:r>
           </a:p>
         </p:txBody>
@@ -2137,7 +2137,7 @@
           <a:lstStyle/>
           <a:p>
             <a:r>
-              <a:t>Chỉ số 0 xuất hiện hai lần trong mẫu của cây 1, trong khi chỉ số 3 không có mặt. Các quan sát không được chọn gọi là out-of-bag đối với cây đó. Với một quan sát cố định, xác suất không chọn ở một lượt là 1 trừ 1/N; qua N lượt độc lập là lũy thừa N. Khi N lớn, xác suất tiến đến e mũ âm một, khoảng 36,8%. Với N bằng 5 trong ví dụ nhỏ, xác suất chính xác là 0,8 mũ 5 bằng 32,768%, không phải đúng 36,8%. Bản nâng cấp tính hard-vote OOB chỉ từ cây chưa thấy mẫu, đồng thời vẫn dùng test riêng để đánh giá. Điểm OOB không độc lập với bước chọn độ sâu trên train.</a:t>
+              <a:t>Ba trang 7–9 dùng xuyên suốt cùng một ví dụ giả lập: x=[1,2,3,4,5], nhãn=[lành,lành,ác,ác,ác]. Ba bootstrap được chọn cố định để nhìn rõ sự khác nhau giữa cây; trong Bagging thực nghiệm, chúng được lấy ngẫu nhiên. Chỉ số 0 xuất hiện hai lần trong mẫu h1; chỉ số 3 vắng ở h1, chỉ số 2 vắng ở h2, chỉ số 0 vắng ở h3. Các mẫu vắng được gọi là OOB đối với cây tương ứng. Chạy python examples/toy_bagging.py --output-dir outputs/toy để tái lập toàn bộ bảng, ngưỡng và phiếu. Với N=5, xác suất một mẫu vắng là (4/5)^5=32,768%; khi N lớn mới gần 36,8%. Các bản bootstrap cụ thể được chọn để dạy cơ chế, không dùng làm thực nghiệm đánh giá hiệu năng.</a:t>
             </a:r>
           </a:p>
         </p:txBody>
@@ -2207,7 +2207,7 @@
           <a:lstStyle/>
           <a:p>
             <a:r>
-              <a:t>Đây là dữ liệu một chiều giả lập để có thể tính tay, không phải các quan sát của Breast Cancer. Cây 1 dùng bootstrap [0,0,2,4,1], tức là các cặp (1,lành), (1,lành), (3,ác), (5,ác), (2,lành). Gini trước chia bằng 0,48. Với ngưỡng 2,5, nhánh trái có ba mẫu đều lành, nhánh phải có hai mẫu đều ác. Gini mỗi nhánh bằng 0; trung bình có trọng số 3/5 nhân 0 cộng 2/5 nhân 0 cũng bằng 0. Mức giảm là 0,48. Thực tế cây thử các ngưỡng trên nhiều đặc trưng và lặp lại các phép chia đến điều kiện dừng. Trong thí nghiệm độ sâu tối đa là 3.</a:t>
+              <a:t>Đây vẫn là dữ liệu giả lập từ slide 7, không phải quan sát Breast Cancer. Cây h1 nhận (1,lành),(1,lành),(3,ác),(5,ác),(2,lành), nên Gini=1−(3/5)^2−(2/5)^2=0,48. Ngưỡng 2,5 là trung điểm giữa 2 và 3: trái có ba mẫu lành, phải có hai mẫu ác; Gini sau chia=(3/5)×0+(2/5)×0=0. Mức giảm 0,48. Vì Gini không âm, đây là phép chia tối ưu của nút. h2 thiếu x=3 nên ranh giới giữa x=2 và x=4 là 3; h3 có ranh giới 2,5. Mỗi cây ví dụ chỉ sâu một mức; mô hình thật được chọn max_depth bằng CV. Mã ví dụ dùng sklearn tính ngưỡng rồi xuất JSON để đối chiếu phép tính tay.</a:t>
             </a:r>
           </a:p>
         </p:txBody>
@@ -2277,7 +2277,7 @@
           <a:lstStyle/>
           <a:p>
             <a:r>
-              <a:t>I là hàm chỉ thị: đúng thì nhận 1, sai thì nhận 0. Cộng theo tất cả cây cho từng lớp c. Với ba dự đoán giả định [0,1,0], lớp 0 có hai phiếu còn lớp 1 có một phiếu, nên argmax chọn 0, tức ác tính. Đây là ví dụ riêng để tính phép tổng hợp, không khẳng định là đầu ra của ba cây trong ví dụ chia nút trước đó. Trong triển khai dùng 51 cây cho hai lớp nên không hòa phiếu. Nếu áp dụng đa lớp thì số cây lẻ vẫn có thể hòa; hàm argmax khi hòa chọn chỉ số lớp đầu tiên.</a:t>
+              <a:t>Đây là dự đoán thật của ba cây một mức đã học từ chính ba bootstrap ở slide 7. h1 và h3 có ngưỡng 2,5 nên x=2,8 đi sang phải và nhận nhãn ác. h2 có ngưỡng 3 nên x=2,8 đi sang trái và nhận nhãn lành. Hai phiếu ác thắng một phiếu lành. Công thức H(x)=argmax_c Σ_b I[h_b(x)=c]: I là hàm chỉ thị, đếm số cây chọn từng lớp rồi lấy lớp có phiếu lớn nhất. Mẫu mới x=2,8 chưa có nhãn thật nên không kết luận dự đoán đúng hay sai; đây là dữ liệu giả lập, không phải một bệnh nhân. Tỷ lệ 2/3 cũng không phải xác suất bệnh đã hiệu chỉnh. Dùng python examples/toy_bagging.py --output-dir outputs/toy để kiểm tra. Khi hai lớp và 51 cây thì không hòa; đa lớp vẫn có thể hòa, mã chọn lớp đầu trong classes_.</a:t>
             </a:r>
           </a:p>
         </p:txBody>
@@ -5715,8 +5715,8 @@
         </p:nvSpPr>
         <p:spPr>
           <a:xfrm>
-            <a:off x="621792" y="5623560"/>
-            <a:ext cx="7772400" cy="502920"/>
+            <a:off x="621792" y="5321808"/>
+            <a:ext cx="8046720" cy="960120"/>
           </a:xfrm>
           <a:prstGeom prst="rect">
             <a:avLst/>
@@ -5733,7 +5733,7 @@
               <a:spcAft>
                 <a:spcPts val="500"/>
               </a:spcAft>
-              <a:defRPr sz="1400" b="0">
+              <a:defRPr sz="1200" b="0">
                 <a:solidFill>
                   <a:srgbClr val="C9D8DF"/>
                 </a:solidFill>
@@ -5741,7 +5741,39 @@
               </a:defRPr>
             </a:pPr>
             <a:r>
-              <a:t>Nhóm: [Điền tên thành viên]   |   Lớp: [Điền lớp]</a:t>
+              <a:t>Nguyễn Nghĩa Hiếu  •  MSSV: 52400013</a:t>
+            </a:r>
+          </a:p>
+          <a:p>
+            <a:pPr algn="l">
+              <a:spcAft>
+                <a:spcPts val="500"/>
+              </a:spcAft>
+              <a:defRPr sz="1200" b="0">
+                <a:solidFill>
+                  <a:srgbClr val="C9D8DF"/>
+                </a:solidFill>
+                <a:latin typeface="Noto Sans"/>
+              </a:defRPr>
+            </a:pPr>
+            <a:r>
+              <a:t>Trần Quốc Bảo  •  MSSV: 52400102</a:t>
+            </a:r>
+          </a:p>
+          <a:p>
+            <a:pPr algn="l">
+              <a:spcAft>
+                <a:spcPts val="500"/>
+              </a:spcAft>
+              <a:defRPr sz="1200" b="0">
+                <a:solidFill>
+                  <a:srgbClr val="C9D8DF"/>
+                </a:solidFill>
+                <a:latin typeface="Noto Sans"/>
+              </a:defRPr>
+            </a:pPr>
+            <a:r>
+              <a:t>Giảng viên: TS. Trần Lương Quốc Đại</a:t>
             </a:r>
           </a:p>
         </p:txBody>
@@ -6321,7 +6353,7 @@
               </a:defRPr>
             </a:pPr>
             <a:r>
-              <a:t>Boosting: mô hình sau tập trung vào sai sót trước</a:t>
+              <a:t>Boosting: học tiếp từ những sai sót trước</a:t>
             </a:r>
           </a:p>
         </p:txBody>
@@ -6434,7 +6466,7 @@
               </a:defRPr>
             </a:pPr>
             <a:r>
-              <a:t>[3], [6]</a:t>
+              <a:t>[3], [6] • Giới thiệu; chưa chạy thực nghiệm Boosting</a:t>
             </a:r>
           </a:p>
         </p:txBody>
@@ -6984,7 +7016,7 @@
         <p:spPr>
           <a:xfrm>
             <a:off x="640080" y="3246120"/>
-            <a:ext cx="5074920" cy="731520"/>
+            <a:ext cx="5120640" cy="731520"/>
           </a:xfrm>
           <a:prstGeom prst="rect">
             <a:avLst/>
@@ -7025,7 +7057,7 @@
               </a:defRPr>
             </a:pPr>
             <a:r>
-              <a:t>ε = 0,20  →  α = ½ ln(0,8/0,2) ≈ 0,693</a:t>
+              <a:t>Tăng chú ý vào mẫu bị dự đoán sai.</a:t>
             </a:r>
           </a:p>
         </p:txBody>
@@ -7039,7 +7071,7 @@
         <p:spPr>
           <a:xfrm>
             <a:off x="640080" y="4343400"/>
-            <a:ext cx="5074920" cy="1325880"/>
+            <a:ext cx="5120640" cy="1325880"/>
           </a:xfrm>
           <a:prstGeom prst="rect">
             <a:avLst/>
@@ -7064,7 +7096,7 @@
               </a:defRPr>
             </a:pPr>
             <a:r>
-              <a:t>Mẫu sai: nhân exp(+α) ≈ 2</a:t>
+              <a:t>Mẫu sai: tăng trọng số.</a:t>
             </a:r>
           </a:p>
           <a:p>
@@ -7080,7 +7112,7 @@
               </a:defRPr>
             </a:pPr>
             <a:r>
-              <a:t>Mẫu đúng: nhân exp(−α) ≈ 0,5</a:t>
+              <a:t>Mẫu đúng: giảm trọng số tương đối.</a:t>
             </a:r>
           </a:p>
           <a:p>
@@ -7096,7 +7128,7 @@
               </a:defRPr>
             </a:pPr>
             <a:r>
-              <a:t>Sau đó chuẩn hóa tổng trọng số về 1.</a:t>
+              <a:t>Mô hình sau học lại trên các trọng số mới.</a:t>
             </a:r>
           </a:p>
         </p:txBody>
@@ -7262,7 +7294,7 @@
               </a:defRPr>
             </a:pPr>
             <a:r>
-              <a:t>Khối lượng trọng số nhóm sai:</a:t>
+              <a:t>Trong ví dụ, nhóm mẫu sai</a:t>
             </a:r>
           </a:p>
           <a:p>
@@ -7278,7 +7310,23 @@
               </a:defRPr>
             </a:pPr>
             <a:r>
-              <a:t>0,2 × 2 / (0,2 × 2 + 0,8 × 0,5) = 0,5.</a:t>
+              <a:t>đang mang 20% tổng trọng số;</a:t>
+            </a:r>
+          </a:p>
+          <a:p>
+            <a:pPr algn="l">
+              <a:spcAft>
+                <a:spcPts val="500"/>
+              </a:spcAft>
+              <a:defRPr sz="1800" b="0">
+                <a:solidFill>
+                  <a:srgbClr val="566A76"/>
+                </a:solidFill>
+                <a:latin typeface="Noto Sans"/>
+              </a:defRPr>
+            </a:pPr>
+            <a:r>
+              <a:t>sau cập nhật mang 50%.</a:t>
             </a:r>
           </a:p>
         </p:txBody>
@@ -21994,7 +22042,7 @@
               </a:defRPr>
             </a:pPr>
             <a:r>
-              <a:t>Demo nhanh hoặc chạy đầy đủ 10 seed</a:t>
+              <a:t>Demo: hiểu cơ chế trước, xem kết quả sau</a:t>
             </a:r>
           </a:p>
         </p:txBody>
@@ -22107,7 +22155,7 @@
               </a:defRPr>
             </a:pPr>
             <a:r>
-              <a:t>Điều phối: de_5_ensemble_learning.py • Mô hình: ensemble_model.py</a:t>
+              <a:t>Ví dụ tính tay → mô hình trên dữ liệu Breast Cancer</a:t>
             </a:r>
           </a:p>
         </p:txBody>
@@ -22222,7 +22270,7 @@
               <a:spcAft>
                 <a:spcPts val="500"/>
               </a:spcAft>
-              <a:defRPr sz="1700" b="0">
+              <a:defRPr sz="1600" b="0">
                 <a:solidFill>
                   <a:srgbClr val="79E2CC"/>
                 </a:solidFill>
@@ -22230,23 +22278,23 @@
               </a:defRPr>
             </a:pPr>
             <a:r>
+              <a:t>python examples/toy_bagging.py --output-dir outputs/toy</a:t>
+            </a:r>
+          </a:p>
+          <a:p>
+            <a:pPr algn="l">
+              <a:spcAft>
+                <a:spcPts val="500"/>
+              </a:spcAft>
+              <a:defRPr sz="1600" b="0">
+                <a:solidFill>
+                  <a:srgbClr val="79E2CC"/>
+                </a:solidFill>
+                <a:latin typeface="DejaVu Sans Mono"/>
+              </a:defRPr>
+            </a:pPr>
+            <a:r>
               <a:t>python de_5_ensemble_learning.py --repeats 1 --output-dir outputs/quick</a:t>
-            </a:r>
-          </a:p>
-          <a:p>
-            <a:pPr algn="l">
-              <a:spcAft>
-                <a:spcPts val="500"/>
-              </a:spcAft>
-              <a:defRPr sz="1700" b="0">
-                <a:solidFill>
-                  <a:srgbClr val="79E2CC"/>
-                </a:solidFill>
-                <a:latin typeface="DejaVu Sans Mono"/>
-              </a:defRPr>
-            </a:pPr>
-            <a:r>
-              <a:t>python de_5_ensemble_learning.py                 # 10 seed</a:t>
             </a:r>
           </a:p>
         </p:txBody>
@@ -28868,7 +28916,7 @@
               </a:defRPr>
             </a:pPr>
             <a:r>
-              <a:t>Đa dạng giúp giảm phương sai</a:t>
+              <a:t>Vì sao Bagging có thể ổn định hơn?</a:t>
             </a:r>
           </a:p>
         </p:txBody>
@@ -29027,234 +29075,14 @@
       </p:sp>
       <p:sp>
         <p:nvSpPr>
-          <p:cNvPr id="9" name="TextBox 8"/>
-          <p:cNvSpPr txBox="1"/>
-          <p:nvPr/>
-        </p:nvSpPr>
-        <p:spPr>
-          <a:xfrm>
-            <a:off x="594360" y="1737360"/>
-            <a:ext cx="10789920" cy="594360"/>
-          </a:xfrm>
-          <a:prstGeom prst="rect">
-            <a:avLst/>
-          </a:prstGeom>
-          <a:noFill/>
-        </p:spPr>
-        <p:txBody>
-          <a:bodyPr wrap="square" lIns="9144" rIns="9144" tIns="9144" bIns="9144" anchor="t">
-            <a:spAutoFit/>
-          </a:bodyPr>
-          <a:lstStyle/>
-          <a:p>
-            <a:pPr algn="l">
-              <a:spcAft>
-                <a:spcPts val="500"/>
-              </a:spcAft>
-              <a:defRPr sz="2900" b="1">
-                <a:solidFill>
-                  <a:srgbClr val="79E2CC"/>
-                </a:solidFill>
-                <a:latin typeface="Noto Sans"/>
-              </a:defRPr>
-            </a:pPr>
-            <a:r>
-              <a:t>Var(trung bình) = σ² [ ρ + (1 − ρ) / B ]</a:t>
-            </a:r>
-          </a:p>
-        </p:txBody>
-      </p:sp>
-      <p:sp>
-        <p:nvSpPr>
-          <p:cNvPr id="10" name="TextBox 9"/>
-          <p:cNvSpPr txBox="1"/>
-          <p:nvPr/>
-        </p:nvSpPr>
-        <p:spPr>
-          <a:xfrm>
-            <a:off x="612648" y="2514600"/>
-            <a:ext cx="4983480" cy="1234440"/>
-          </a:xfrm>
-          <a:prstGeom prst="rect">
-            <a:avLst/>
-          </a:prstGeom>
-          <a:noFill/>
-        </p:spPr>
-        <p:txBody>
-          <a:bodyPr wrap="square" lIns="9144" rIns="9144" tIns="9144" bIns="9144" anchor="t">
-            <a:spAutoFit/>
-          </a:bodyPr>
-          <a:lstStyle/>
-          <a:p>
-            <a:pPr algn="l">
-              <a:spcAft>
-                <a:spcPts val="500"/>
-              </a:spcAft>
-              <a:defRPr sz="2000" b="0">
-                <a:solidFill>
-                  <a:srgbClr val="FFFFFF"/>
-                </a:solidFill>
-                <a:latin typeface="Noto Sans"/>
-              </a:defRPr>
-            </a:pPr>
-            <a:r>
-              <a:t>B: số mô hình</a:t>
-            </a:r>
-          </a:p>
-          <a:p>
-            <a:pPr algn="l">
-              <a:spcAft>
-                <a:spcPts val="500"/>
-              </a:spcAft>
-              <a:defRPr sz="2000" b="0">
-                <a:solidFill>
-                  <a:srgbClr val="FFFFFF"/>
-                </a:solidFill>
-                <a:latin typeface="Noto Sans"/>
-              </a:defRPr>
-            </a:pPr>
-            <a:r>
-              <a:t>σ²: phương sai của mỗi mô hình</a:t>
-            </a:r>
-          </a:p>
-          <a:p>
-            <a:pPr algn="l">
-              <a:spcAft>
-                <a:spcPts val="500"/>
-              </a:spcAft>
-              <a:defRPr sz="2000" b="0">
-                <a:solidFill>
-                  <a:srgbClr val="FFFFFF"/>
-                </a:solidFill>
-                <a:latin typeface="Noto Sans"/>
-              </a:defRPr>
-            </a:pPr>
-            <a:r>
-              <a:t>ρ: tương quan giữa hai mô hình</a:t>
-            </a:r>
-          </a:p>
-        </p:txBody>
-      </p:sp>
-      <p:sp>
-        <p:nvSpPr>
-          <p:cNvPr id="11" name="TextBox 10"/>
-          <p:cNvSpPr txBox="1"/>
-          <p:nvPr/>
-        </p:nvSpPr>
-        <p:spPr>
-          <a:xfrm>
-            <a:off x="612648" y="4114800"/>
-            <a:ext cx="4754880" cy="1463040"/>
-          </a:xfrm>
-          <a:prstGeom prst="rect">
-            <a:avLst/>
-          </a:prstGeom>
-          <a:noFill/>
-        </p:spPr>
-        <p:txBody>
-          <a:bodyPr wrap="square" lIns="9144" rIns="9144" tIns="9144" bIns="9144" anchor="t">
-            <a:spAutoFit/>
-          </a:bodyPr>
-          <a:lstStyle/>
-          <a:p>
-            <a:pPr algn="l">
-              <a:spcAft>
-                <a:spcPts val="500"/>
-              </a:spcAft>
-              <a:defRPr sz="2100" b="0">
-                <a:solidFill>
-                  <a:srgbClr val="C9D8DF"/>
-                </a:solidFill>
-                <a:latin typeface="Noto Sans"/>
-              </a:defRPr>
-            </a:pPr>
-            <a:r>
-              <a:t>Thêm mô hình giảm phần (1 − ρ)/B.</a:t>
-            </a:r>
-          </a:p>
-          <a:p>
-            <a:pPr algn="l">
-              <a:spcAft>
-                <a:spcPts val="500"/>
-              </a:spcAft>
-              <a:defRPr sz="2100" b="0">
-                <a:solidFill>
-                  <a:srgbClr val="C9D8DF"/>
-                </a:solidFill>
-                <a:latin typeface="Noto Sans"/>
-              </a:defRPr>
-            </a:pPr>
-            <a:r>
-              <a:t>Phần ρ vẫn tạo ra giới hạn:</a:t>
-            </a:r>
-          </a:p>
-          <a:p>
-            <a:pPr algn="l">
-              <a:spcAft>
-                <a:spcPts val="500"/>
-              </a:spcAft>
-              <a:defRPr sz="2100" b="0">
-                <a:solidFill>
-                  <a:srgbClr val="C9D8DF"/>
-                </a:solidFill>
-                <a:latin typeface="Noto Sans"/>
-              </a:defRPr>
-            </a:pPr>
-            <a:r>
-              <a:t>các mô hình quá giống nhau ít có lợi.</a:t>
-            </a:r>
-          </a:p>
-        </p:txBody>
-      </p:sp>
-      <p:sp>
-        <p:nvSpPr>
-          <p:cNvPr id="12" name="TextBox 11"/>
-          <p:cNvSpPr txBox="1"/>
-          <p:nvPr/>
-        </p:nvSpPr>
-        <p:spPr>
-          <a:xfrm>
-            <a:off x="6080760" y="2834640"/>
-            <a:ext cx="4937760" cy="365760"/>
-          </a:xfrm>
-          <a:prstGeom prst="rect">
-            <a:avLst/>
-          </a:prstGeom>
-          <a:noFill/>
-        </p:spPr>
-        <p:txBody>
-          <a:bodyPr wrap="square" lIns="9144" rIns="9144" tIns="9144" bIns="9144" anchor="t">
-            <a:spAutoFit/>
-          </a:bodyPr>
-          <a:lstStyle/>
-          <a:p>
-            <a:pPr algn="l">
-              <a:spcAft>
-                <a:spcPts val="500"/>
-              </a:spcAft>
-              <a:defRPr sz="2000" b="1">
-                <a:solidFill>
-                  <a:srgbClr val="FFFFFF"/>
-                </a:solidFill>
-                <a:latin typeface="Noto Sans"/>
-              </a:defRPr>
-            </a:pPr>
-            <a:r>
-              <a:t>B = 51, ρ = 0,2  →  0,216 σ²</a:t>
-            </a:r>
-          </a:p>
-        </p:txBody>
-      </p:sp>
-      <p:sp>
-        <p:nvSpPr>
-          <p:cNvPr id="13" name="Rounded Rectangle 12"/>
+          <p:cNvPr id="9" name="Rounded Rectangle 8"/>
           <p:cNvSpPr/>
           <p:nvPr/>
         </p:nvSpPr>
         <p:spPr>
           <a:xfrm>
-            <a:off x="6080760" y="3383280"/>
-            <a:ext cx="4846320" cy="256032"/>
+            <a:off x="594360" y="1783080"/>
+            <a:ext cx="5303520" cy="3520440"/>
           </a:xfrm>
           <a:prstGeom prst="roundRect">
             <a:avLst>
@@ -29262,7 +29090,7 @@
             </a:avLst>
           </a:prstGeom>
           <a:solidFill>
-            <a:srgbClr val="28485A"/>
+            <a:srgbClr val="1C384B"/>
           </a:solidFill>
           <a:ln>
             <a:noFill/>
@@ -29292,19 +29120,17 @@
       </p:sp>
       <p:sp>
         <p:nvSpPr>
-          <p:cNvPr id="14" name="Rounded Rectangle 13"/>
+          <p:cNvPr id="10" name="Rectangle 9"/>
           <p:cNvSpPr/>
           <p:nvPr/>
         </p:nvSpPr>
         <p:spPr>
           <a:xfrm>
-            <a:off x="6080760" y="3383280"/>
-            <a:ext cx="1045284" cy="256032"/>
-          </a:xfrm>
-          <a:prstGeom prst="roundRect">
-            <a:avLst>
-              <a:gd name="adj" fmla="val 12000"/>
-            </a:avLst>
+            <a:off x="795528" y="2011680"/>
+            <a:ext cx="384048" cy="50292"/>
+          </a:xfrm>
+          <a:prstGeom prst="rect">
+            <a:avLst/>
           </a:prstGeom>
           <a:solidFill>
             <a:srgbClr val="79E2CC"/>
@@ -29337,14 +29163,14 @@
       </p:sp>
       <p:sp>
         <p:nvSpPr>
-          <p:cNvPr id="15" name="TextBox 14"/>
-          <p:cNvSpPr txBox="1"/>
-          <p:nvPr/>
-        </p:nvSpPr>
-        <p:spPr>
-          <a:xfrm>
-            <a:off x="6080760" y="4160520"/>
-            <a:ext cx="4937760" cy="365760"/>
+          <p:cNvPr id="11" name="TextBox 10"/>
+          <p:cNvSpPr txBox="1"/>
+          <p:nvPr/>
+        </p:nvSpPr>
+        <p:spPr>
+          <a:xfrm>
+            <a:off x="822960" y="2203704"/>
+            <a:ext cx="4846320" cy="685800"/>
           </a:xfrm>
           <a:prstGeom prst="rect">
             <a:avLst/>
@@ -29361,7 +29187,7 @@
               <a:spcAft>
                 <a:spcPts val="500"/>
               </a:spcAft>
-              <a:defRPr sz="2000" b="1">
+              <a:defRPr sz="2300" b="1">
                 <a:solidFill>
                   <a:srgbClr val="FFFFFF"/>
                 </a:solidFill>
@@ -29369,21 +29195,121 @@
               </a:defRPr>
             </a:pPr>
             <a:r>
-              <a:t>B = 51, ρ = 0,8  →  0,804 σ²</a:t>
-            </a:r>
-          </a:p>
-        </p:txBody>
-      </p:sp>
-      <p:sp>
-        <p:nvSpPr>
-          <p:cNvPr id="16" name="Rounded Rectangle 15"/>
+              <a:t>MỘT CÂY DỄ DAO ĐỘNG</a:t>
+            </a:r>
+          </a:p>
+        </p:txBody>
+      </p:sp>
+      <p:sp>
+        <p:nvSpPr>
+          <p:cNvPr id="12" name="TextBox 11"/>
+          <p:cNvSpPr txBox="1"/>
+          <p:nvPr/>
+        </p:nvSpPr>
+        <p:spPr>
+          <a:xfrm>
+            <a:off x="822960" y="2953512"/>
+            <a:ext cx="4846320" cy="2240280"/>
+          </a:xfrm>
+          <a:prstGeom prst="rect">
+            <a:avLst/>
+          </a:prstGeom>
+          <a:noFill/>
+        </p:spPr>
+        <p:txBody>
+          <a:bodyPr wrap="square" lIns="9144" rIns="9144" tIns="9144" bIns="9144" anchor="t">
+            <a:spAutoFit/>
+          </a:bodyPr>
+          <a:lstStyle/>
+          <a:p>
+            <a:pPr algn="l">
+              <a:spcAft>
+                <a:spcPts val="500"/>
+              </a:spcAft>
+              <a:defRPr sz="1800" b="0">
+                <a:solidFill>
+                  <a:srgbClr val="C9D8DF"/>
+                </a:solidFill>
+                <a:latin typeface="Noto Sans"/>
+              </a:defRPr>
+            </a:pPr>
+            <a:r>
+              <a:t>Đổi một phần dữ liệu train</a:t>
+            </a:r>
+          </a:p>
+          <a:p>
+            <a:pPr algn="l">
+              <a:spcAft>
+                <a:spcPts val="500"/>
+              </a:spcAft>
+              <a:defRPr sz="1800" b="0">
+                <a:solidFill>
+                  <a:srgbClr val="C9D8DF"/>
+                </a:solidFill>
+                <a:latin typeface="Noto Sans"/>
+              </a:defRPr>
+            </a:pPr>
+            <a:r>
+              <a:t>→ ngưỡng chia có thể đổi</a:t>
+            </a:r>
+          </a:p>
+          <a:p>
+            <a:pPr algn="l">
+              <a:spcAft>
+                <a:spcPts val="500"/>
+              </a:spcAft>
+              <a:defRPr sz="1800" b="0">
+                <a:solidFill>
+                  <a:srgbClr val="C9D8DF"/>
+                </a:solidFill>
+                <a:latin typeface="Noto Sans"/>
+              </a:defRPr>
+            </a:pPr>
+            <a:r>
+              <a:t>→ dự đoán có thể đổi.</a:t>
+            </a:r>
+          </a:p>
+          <a:p>
+            <a:pPr algn="l">
+              <a:spcAft>
+                <a:spcPts val="500"/>
+              </a:spcAft>
+              <a:defRPr sz="1800" b="0">
+                <a:solidFill>
+                  <a:srgbClr val="C9D8DF"/>
+                </a:solidFill>
+                <a:latin typeface="Noto Sans"/>
+              </a:defRPr>
+            </a:pPr>
+          </a:p>
+          <a:p>
+            <a:pPr algn="l">
+              <a:spcAft>
+                <a:spcPts val="500"/>
+              </a:spcAft>
+              <a:defRPr sz="1800" b="0">
+                <a:solidFill>
+                  <a:srgbClr val="C9D8DF"/>
+                </a:solidFill>
+                <a:latin typeface="Noto Sans"/>
+              </a:defRPr>
+            </a:pPr>
+            <a:r>
+              <a:t>Đó là trực giác về phương sai.</a:t>
+            </a:r>
+          </a:p>
+        </p:txBody>
+      </p:sp>
+      <p:sp>
+        <p:nvSpPr>
+          <p:cNvPr id="13" name="Rounded Rectangle 12"/>
           <p:cNvSpPr/>
           <p:nvPr/>
         </p:nvSpPr>
         <p:spPr>
           <a:xfrm>
-            <a:off x="6080760" y="4709159"/>
-            <a:ext cx="4846320" cy="256032"/>
+            <a:off x="6126480" y="1783080"/>
+            <a:ext cx="5440680" cy="3520440"/>
           </a:xfrm>
           <a:prstGeom prst="roundRect">
             <a:avLst>
@@ -29391,7 +29317,7 @@
             </a:avLst>
           </a:prstGeom>
           <a:solidFill>
-            <a:srgbClr val="28485A"/>
+            <a:srgbClr val="1C384B"/>
           </a:solidFill>
           <a:ln>
             <a:noFill/>
@@ -29421,19 +29347,17 @@
       </p:sp>
       <p:sp>
         <p:nvSpPr>
-          <p:cNvPr id="17" name="Rounded Rectangle 16"/>
+          <p:cNvPr id="14" name="Rectangle 13"/>
           <p:cNvSpPr/>
           <p:nvPr/>
         </p:nvSpPr>
         <p:spPr>
           <a:xfrm>
-            <a:off x="6080760" y="4709159"/>
-            <a:ext cx="3896061" cy="256032"/>
-          </a:xfrm>
-          <a:prstGeom prst="roundRect">
-            <a:avLst>
-              <a:gd name="adj" fmla="val 12000"/>
-            </a:avLst>
+            <a:off x="6327648" y="2011680"/>
+            <a:ext cx="384048" cy="50292"/>
+          </a:xfrm>
+          <a:prstGeom prst="rect">
+            <a:avLst/>
           </a:prstGeom>
           <a:solidFill>
             <a:srgbClr val="E67B47"/>
@@ -29466,14 +29390,14 @@
       </p:sp>
       <p:sp>
         <p:nvSpPr>
-          <p:cNvPr id="18" name="TextBox 17"/>
-          <p:cNvSpPr txBox="1"/>
-          <p:nvPr/>
-        </p:nvSpPr>
-        <p:spPr>
-          <a:xfrm>
-            <a:off x="6080760" y="5532120"/>
-            <a:ext cx="5166360" cy="594360"/>
+          <p:cNvPr id="15" name="TextBox 14"/>
+          <p:cNvSpPr txBox="1"/>
+          <p:nvPr/>
+        </p:nvSpPr>
+        <p:spPr>
+          <a:xfrm>
+            <a:off x="6355080" y="2203704"/>
+            <a:ext cx="4983480" cy="685800"/>
           </a:xfrm>
           <a:prstGeom prst="rect">
             <a:avLst/>
@@ -29490,7 +29414,46 @@
               <a:spcAft>
                 <a:spcPts val="500"/>
               </a:spcAft>
-              <a:defRPr sz="1300" b="0">
+              <a:defRPr sz="2300" b="1">
+                <a:solidFill>
+                  <a:srgbClr val="FFFFFF"/>
+                </a:solidFill>
+                <a:latin typeface="Noto Sans"/>
+              </a:defRPr>
+            </a:pPr>
+            <a:r>
+              <a:t>NHIỀU CÂY BÙ LỖI</a:t>
+            </a:r>
+          </a:p>
+        </p:txBody>
+      </p:sp>
+      <p:sp>
+        <p:nvSpPr>
+          <p:cNvPr id="16" name="TextBox 15"/>
+          <p:cNvSpPr txBox="1"/>
+          <p:nvPr/>
+        </p:nvSpPr>
+        <p:spPr>
+          <a:xfrm>
+            <a:off x="6355080" y="2953512"/>
+            <a:ext cx="4983480" cy="2240280"/>
+          </a:xfrm>
+          <a:prstGeom prst="rect">
+            <a:avLst/>
+          </a:prstGeom>
+          <a:noFill/>
+        </p:spPr>
+        <p:txBody>
+          <a:bodyPr wrap="square" lIns="9144" rIns="9144" tIns="9144" bIns="9144" anchor="t">
+            <a:spAutoFit/>
+          </a:bodyPr>
+          <a:lstStyle/>
+          <a:p>
+            <a:pPr algn="l">
+              <a:spcAft>
+                <a:spcPts val="500"/>
+              </a:spcAft>
+              <a:defRPr sz="1800" b="0">
                 <a:solidFill>
                   <a:srgbClr val="C9D8DF"/>
                 </a:solidFill>
@@ -29498,7 +29461,123 @@
               </a:defRPr>
             </a:pPr>
             <a:r>
-              <a:t>Giả thiết: cùng phương sai và tương quan cặp chung; áp dụng cho trung bình dự đoán số.</a:t>
+              <a:t>Bootstrap tạo nhiều tập train.</a:t>
+            </a:r>
+          </a:p>
+          <a:p>
+            <a:pPr algn="l">
+              <a:spcAft>
+                <a:spcPts val="500"/>
+              </a:spcAft>
+              <a:defRPr sz="1800" b="0">
+                <a:solidFill>
+                  <a:srgbClr val="C9D8DF"/>
+                </a:solidFill>
+                <a:latin typeface="Noto Sans"/>
+              </a:defRPr>
+            </a:pPr>
+            <a:r>
+              <a:t>Mỗi cây học hơi khác nhau.</a:t>
+            </a:r>
+          </a:p>
+          <a:p>
+            <a:pPr algn="l">
+              <a:spcAft>
+                <a:spcPts val="500"/>
+              </a:spcAft>
+              <a:defRPr sz="1800" b="0">
+                <a:solidFill>
+                  <a:srgbClr val="C9D8DF"/>
+                </a:solidFill>
+                <a:latin typeface="Noto Sans"/>
+              </a:defRPr>
+            </a:pPr>
+            <a:r>
+              <a:t>Voting giảm ảnh hưởng của</a:t>
+            </a:r>
+          </a:p>
+          <a:p>
+            <a:pPr algn="l">
+              <a:spcAft>
+                <a:spcPts val="500"/>
+              </a:spcAft>
+              <a:defRPr sz="1800" b="0">
+                <a:solidFill>
+                  <a:srgbClr val="C9D8DF"/>
+                </a:solidFill>
+                <a:latin typeface="Noto Sans"/>
+              </a:defRPr>
+            </a:pPr>
+            <a:r>
+              <a:t>một dự đoán riêng lẻ.</a:t>
+            </a:r>
+          </a:p>
+          <a:p>
+            <a:pPr algn="l">
+              <a:spcAft>
+                <a:spcPts val="500"/>
+              </a:spcAft>
+              <a:defRPr sz="1800" b="0">
+                <a:solidFill>
+                  <a:srgbClr val="C9D8DF"/>
+                </a:solidFill>
+                <a:latin typeface="Noto Sans"/>
+              </a:defRPr>
+            </a:pPr>
+          </a:p>
+          <a:p>
+            <a:pPr algn="l">
+              <a:spcAft>
+                <a:spcPts val="500"/>
+              </a:spcAft>
+              <a:defRPr sz="1800" b="0">
+                <a:solidFill>
+                  <a:srgbClr val="C9D8DF"/>
+                </a:solidFill>
+                <a:latin typeface="Noto Sans"/>
+              </a:defRPr>
+            </a:pPr>
+            <a:r>
+              <a:t>Cùng sai thì vẫn có thể sai.</a:t>
+            </a:r>
+          </a:p>
+        </p:txBody>
+      </p:sp>
+      <p:sp>
+        <p:nvSpPr>
+          <p:cNvPr id="17" name="TextBox 16"/>
+          <p:cNvSpPr txBox="1"/>
+          <p:nvPr/>
+        </p:nvSpPr>
+        <p:spPr>
+          <a:xfrm>
+            <a:off x="640080" y="5532120"/>
+            <a:ext cx="10881360" cy="411480"/>
+          </a:xfrm>
+          <a:prstGeom prst="rect">
+            <a:avLst/>
+          </a:prstGeom>
+          <a:noFill/>
+        </p:spPr>
+        <p:txBody>
+          <a:bodyPr wrap="square" lIns="9144" rIns="9144" tIns="9144" bIns="9144" anchor="t">
+            <a:spAutoFit/>
+          </a:bodyPr>
+          <a:lstStyle/>
+          <a:p>
+            <a:pPr algn="l">
+              <a:spcAft>
+                <a:spcPts val="500"/>
+              </a:spcAft>
+              <a:defRPr sz="1900" b="1">
+                <a:solidFill>
+                  <a:srgbClr val="79E2CC"/>
+                </a:solidFill>
+                <a:latin typeface="Noto Sans"/>
+              </a:defRPr>
+            </a:pPr>
+            <a:r>
+              <a:t>Chìa khóa: cây đủ tốt + lỗi không quá giống nhau; thêm cây không bảo đảm tốt hơn.</a:t>
             </a:r>
           </a:p>
         </p:txBody>
@@ -32724,7 +32803,7 @@
               </a:defRPr>
             </a:pPr>
             <a:r>
-              <a:t>Ví dụ minh họa; lý thuyết bootstrap: [1]</a:t>
+              <a:t>Dữ liệu giả lập • examples/toy_bagging.py • Bootstrap: [1]</a:t>
             </a:r>
           </a:p>
         </p:txBody>
@@ -32777,7 +32856,7 @@
         <p:spPr>
           <a:xfrm>
             <a:off x="594360" y="1691640"/>
-            <a:ext cx="10789920" cy="365760"/>
+            <a:ext cx="10789920" cy="457200"/>
           </a:xfrm>
           <a:prstGeom prst="rect">
             <a:avLst/>
@@ -32802,7 +32881,7 @@
               </a:defRPr>
             </a:pPr>
             <a:r>
-              <a:t>Tập gốc có chỉ số [0, 1, 2, 3, 4]. Mỗi dòng là một mẫu huấn luyện mới.</a:t>
+              <a:t>Cùng 5 mẫu có x = [1, 2, 3, 4, 5]. Lấy mẫu theo chỉ số đếm từ 0.</a:t>
             </a:r>
           </a:p>
         </p:txBody>
@@ -33130,7 +33209,7 @@
               </a:defRPr>
             </a:pPr>
             <a:r>
-              <a:t>h₁</a:t>
+              <a:t>h1</a:t>
             </a:r>
           </a:p>
         </p:txBody>
@@ -33376,7 +33455,7 @@
               </a:defRPr>
             </a:pPr>
             <a:r>
-              <a:t>h₂</a:t>
+              <a:t>h2</a:t>
             </a:r>
           </a:p>
         </p:txBody>
@@ -33458,7 +33537,7 @@
               </a:defRPr>
             </a:pPr>
             <a:r>
-              <a:t>[1, 3, 3, 2, 0]</a:t>
+              <a:t>[0, 0, 1, 3, 4]</a:t>
             </a:r>
           </a:p>
         </p:txBody>
@@ -33540,7 +33619,7 @@
               </a:defRPr>
             </a:pPr>
             <a:r>
-              <a:t>4</a:t>
+              <a:t>2</a:t>
             </a:r>
           </a:p>
         </p:txBody>
@@ -33622,7 +33701,7 @@
               </a:defRPr>
             </a:pPr>
             <a:r>
-              <a:t>h₃</a:t>
+              <a:t>h3</a:t>
             </a:r>
           </a:p>
         </p:txBody>
@@ -36039,7 +36118,7 @@
     <p:bg>
       <p:bgPr>
         <a:solidFill>
-          <a:srgbClr val="102537"/>
+          <a:srgbClr val="F7F5EE"/>
         </a:solidFill>
         <a:effectLst/>
       </p:bgPr>
@@ -36066,7 +36145,7 @@
             <a:avLst/>
           </a:prstGeom>
           <a:solidFill>
-            <a:srgbClr val="79E2CC"/>
+            <a:srgbClr val="087E83"/>
           </a:solidFill>
           <a:ln>
             <a:noFill/>
@@ -36122,7 +36201,7 @@
               </a:spcAft>
               <a:defRPr sz="1000" b="1">
                 <a:solidFill>
-                  <a:srgbClr val="79E2CC"/>
+                  <a:srgbClr val="087E83"/>
                 </a:solidFill>
                 <a:latin typeface="Noto Sans"/>
               </a:defRPr>
@@ -36161,13 +36240,13 @@
               </a:spcAft>
               <a:defRPr sz="3000" b="1">
                 <a:solidFill>
-                  <a:srgbClr val="FFFFFF"/>
-                </a:solidFill>
-                <a:latin typeface="Noto Sans"/>
-              </a:defRPr>
-            </a:pPr>
-            <a:r>
-              <a:t>Từ phiếu riêng lẻ đến quyết định của tổ hợp</a:t>
+                  <a:srgbClr val="173246"/>
+                </a:solidFill>
+                <a:latin typeface="Noto Sans"/>
+              </a:defRPr>
+            </a:pPr>
+            <a:r>
+              <a:t>Cùng một mẫu mới, ba cây cho hai phía phiếu</a:t>
             </a:r>
           </a:p>
         </p:txBody>
@@ -36188,7 +36267,7 @@
           </a:prstGeom>
           <a:ln w="8890">
             <a:solidFill>
-              <a:srgbClr val="375161"/>
+              <a:srgbClr val="D3DFDA"/>
             </a:solidFill>
           </a:ln>
         </p:spPr>
@@ -36235,7 +36314,7 @@
               </a:spcAft>
               <a:defRPr sz="800" b="0">
                 <a:solidFill>
-                  <a:srgbClr val="AFC4CF"/>
+                  <a:srgbClr val="566A76"/>
                 </a:solidFill>
                 <a:latin typeface="Noto Sans"/>
               </a:defRPr>
@@ -36274,13 +36353,13 @@
               </a:spcAft>
               <a:defRPr sz="800" b="0">
                 <a:solidFill>
-                  <a:srgbClr val="AFC4CF"/>
-                </a:solidFill>
-                <a:latin typeface="Noto Sans"/>
-              </a:defRPr>
-            </a:pPr>
-            <a:r>
-              <a:t>Ví dụ phiếu giả định; không phải đầu ra thí nghiệm</a:t>
+                  <a:srgbClr val="566A76"/>
+                </a:solidFill>
+                <a:latin typeface="Noto Sans"/>
+              </a:defRPr>
+            </a:pPr>
+            <a:r>
+              <a:t>Cùng ví dụ slide 7–8 • Số liệu tính bởi examples/toy_bagging.py</a:t>
             </a:r>
           </a:p>
         </p:txBody>
@@ -36313,7 +36392,7 @@
               </a:spcAft>
               <a:defRPr sz="1000" b="1">
                 <a:solidFill>
-                  <a:srgbClr val="79E2CC"/>
+                  <a:srgbClr val="087E83"/>
                 </a:solidFill>
                 <a:latin typeface="Noto Sans"/>
               </a:defRPr>
@@ -36333,7 +36412,7 @@
         <p:spPr>
           <a:xfrm>
             <a:off x="640080" y="1691640"/>
-            <a:ext cx="10972800" cy="640080"/>
+            <a:ext cx="10881360" cy="457200"/>
           </a:xfrm>
           <a:prstGeom prst="rect">
             <a:avLst/>
@@ -36350,74 +36429,35 @@
               <a:spcAft>
                 <a:spcPts val="500"/>
               </a:spcAft>
-              <a:defRPr sz="3200" b="1">
-                <a:solidFill>
-                  <a:srgbClr val="79E2CC"/>
-                </a:solidFill>
-                <a:latin typeface="Noto Sans"/>
-              </a:defRPr>
-            </a:pPr>
-            <a:r>
-              <a:t>H(x) = argmax꜀  Σᵦ  I[hᵦ(x) = c]</a:t>
-            </a:r>
-          </a:p>
-        </p:txBody>
-      </p:sp>
-      <p:sp>
-        <p:nvSpPr>
-          <p:cNvPr id="10" name="TextBox 9"/>
-          <p:cNvSpPr txBox="1"/>
-          <p:nvPr/>
-        </p:nvSpPr>
-        <p:spPr>
-          <a:xfrm>
-            <a:off x="914400" y="2743200"/>
-            <a:ext cx="2011680" cy="457200"/>
-          </a:xfrm>
-          <a:prstGeom prst="rect">
-            <a:avLst/>
-          </a:prstGeom>
-          <a:noFill/>
-        </p:spPr>
-        <p:txBody>
-          <a:bodyPr wrap="square" lIns="9144" rIns="9144" tIns="9144" bIns="9144" anchor="t">
-            <a:spAutoFit/>
-          </a:bodyPr>
-          <a:lstStyle/>
-          <a:p>
-            <a:pPr algn="ctr">
-              <a:spcAft>
-                <a:spcPts val="500"/>
-              </a:spcAft>
-              <a:defRPr sz="2200" b="1">
-                <a:solidFill>
-                  <a:srgbClr val="FFFFFF"/>
-                </a:solidFill>
-                <a:latin typeface="Noto Sans"/>
-              </a:defRPr>
-            </a:pPr>
-            <a:r>
-              <a:t>h₁(x)</a:t>
-            </a:r>
-          </a:p>
-        </p:txBody>
-      </p:sp>
-      <p:sp>
-        <p:nvSpPr>
-          <p:cNvPr id="11" name="Oval 10"/>
+              <a:defRPr sz="2000" b="0">
+                <a:solidFill>
+                  <a:srgbClr val="566A76"/>
+                </a:solidFill>
+                <a:latin typeface="Noto Sans"/>
+              </a:defRPr>
+            </a:pPr>
+            <a:r>
+              <a:t>Mẫu mới x = 2,8. Mỗi cây: x ≤ ngưỡng → lành; x &gt; ngưỡng → ác.</a:t>
+            </a:r>
+          </a:p>
+        </p:txBody>
+      </p:sp>
+      <p:sp>
+        <p:nvSpPr>
+          <p:cNvPr id="10" name="Rectangle 9"/>
           <p:cNvSpPr/>
           <p:nvPr/>
         </p:nvSpPr>
         <p:spPr>
           <a:xfrm>
-            <a:off x="1234440" y="3474720"/>
-            <a:ext cx="1325880" cy="1325880"/>
-          </a:xfrm>
-          <a:prstGeom prst="ellipse">
+            <a:off x="594360" y="2423160"/>
+            <a:ext cx="1257300" cy="644652"/>
+          </a:xfrm>
+          <a:prstGeom prst="rect">
             <a:avLst/>
           </a:prstGeom>
           <a:solidFill>
-            <a:srgbClr val="087E83"/>
+            <a:srgbClr val="102537"/>
           </a:solidFill>
           <a:ln>
             <a:noFill/>
@@ -36447,31 +36487,31 @@
       </p:sp>
       <p:sp>
         <p:nvSpPr>
-          <p:cNvPr id="12" name="TextBox 11"/>
-          <p:cNvSpPr txBox="1"/>
-          <p:nvPr/>
-        </p:nvSpPr>
-        <p:spPr>
-          <a:xfrm>
-            <a:off x="1234440" y="3753154"/>
-            <a:ext cx="1325880" cy="769010"/>
-          </a:xfrm>
-          <a:prstGeom prst="rect">
-            <a:avLst/>
-          </a:prstGeom>
-          <a:noFill/>
-        </p:spPr>
-        <p:txBody>
-          <a:bodyPr wrap="square" lIns="9144" rIns="9144" tIns="9144" bIns="9144" anchor="t">
-            <a:spAutoFit/>
-          </a:bodyPr>
-          <a:lstStyle/>
-          <a:p>
-            <a:pPr algn="ctr">
-              <a:spcAft>
-                <a:spcPts val="500"/>
-              </a:spcAft>
-              <a:defRPr sz="2300" b="1">
+          <p:cNvPr id="11" name="TextBox 10"/>
+          <p:cNvSpPr txBox="1"/>
+          <p:nvPr/>
+        </p:nvSpPr>
+        <p:spPr>
+          <a:xfrm>
+            <a:off x="731520" y="2532888"/>
+            <a:ext cx="1005839" cy="521207"/>
+          </a:xfrm>
+          <a:prstGeom prst="rect">
+            <a:avLst/>
+          </a:prstGeom>
+          <a:noFill/>
+        </p:spPr>
+        <p:txBody>
+          <a:bodyPr wrap="square" lIns="9144" rIns="9144" tIns="9144" bIns="9144" anchor="t">
+            <a:spAutoFit/>
+          </a:bodyPr>
+          <a:lstStyle/>
+          <a:p>
+            <a:pPr algn="l">
+              <a:spcAft>
+                <a:spcPts val="500"/>
+              </a:spcAft>
+              <a:defRPr sz="1900" b="1">
                 <a:solidFill>
                   <a:srgbClr val="FFFFFF"/>
                 </a:solidFill>
@@ -36479,66 +36519,27 @@
               </a:defRPr>
             </a:pPr>
             <a:r>
-              <a:t>ÁC</a:t>
-            </a:r>
-          </a:p>
-        </p:txBody>
-      </p:sp>
-      <p:sp>
-        <p:nvSpPr>
-          <p:cNvPr id="13" name="TextBox 12"/>
-          <p:cNvSpPr txBox="1"/>
-          <p:nvPr/>
-        </p:nvSpPr>
-        <p:spPr>
-          <a:xfrm>
-            <a:off x="3657600" y="2743200"/>
-            <a:ext cx="2011680" cy="457200"/>
-          </a:xfrm>
-          <a:prstGeom prst="rect">
-            <a:avLst/>
-          </a:prstGeom>
-          <a:noFill/>
-        </p:spPr>
-        <p:txBody>
-          <a:bodyPr wrap="square" lIns="9144" rIns="9144" tIns="9144" bIns="9144" anchor="t">
-            <a:spAutoFit/>
-          </a:bodyPr>
-          <a:lstStyle/>
-          <a:p>
-            <a:pPr algn="ctr">
-              <a:spcAft>
-                <a:spcPts val="500"/>
-              </a:spcAft>
-              <a:defRPr sz="2200" b="1">
-                <a:solidFill>
-                  <a:srgbClr val="FFFFFF"/>
-                </a:solidFill>
-                <a:latin typeface="Noto Sans"/>
-              </a:defRPr>
-            </a:pPr>
-            <a:r>
-              <a:t>h₂(x)</a:t>
-            </a:r>
-          </a:p>
-        </p:txBody>
-      </p:sp>
-      <p:sp>
-        <p:nvSpPr>
-          <p:cNvPr id="14" name="Oval 13"/>
+              <a:t>Cây</a:t>
+            </a:r>
+          </a:p>
+        </p:txBody>
+      </p:sp>
+      <p:sp>
+        <p:nvSpPr>
+          <p:cNvPr id="12" name="Rectangle 11"/>
           <p:cNvSpPr/>
           <p:nvPr/>
         </p:nvSpPr>
         <p:spPr>
           <a:xfrm>
-            <a:off x="3977639" y="3474720"/>
-            <a:ext cx="1325880" cy="1325880"/>
-          </a:xfrm>
-          <a:prstGeom prst="ellipse">
+            <a:off x="1874519" y="2423160"/>
+            <a:ext cx="3268980" cy="644652"/>
+          </a:xfrm>
+          <a:prstGeom prst="rect">
             <a:avLst/>
           </a:prstGeom>
           <a:solidFill>
-            <a:srgbClr val="496273"/>
+            <a:srgbClr val="102537"/>
           </a:solidFill>
           <a:ln>
             <a:noFill/>
@@ -36568,14 +36569,14 @@
       </p:sp>
       <p:sp>
         <p:nvSpPr>
-          <p:cNvPr id="15" name="TextBox 14"/>
-          <p:cNvSpPr txBox="1"/>
-          <p:nvPr/>
-        </p:nvSpPr>
-        <p:spPr>
-          <a:xfrm>
-            <a:off x="3977639" y="3753154"/>
-            <a:ext cx="1325880" cy="769010"/>
+          <p:cNvPr id="13" name="TextBox 12"/>
+          <p:cNvSpPr txBox="1"/>
+          <p:nvPr/>
+        </p:nvSpPr>
+        <p:spPr>
+          <a:xfrm>
+            <a:off x="2011679" y="2532888"/>
+            <a:ext cx="3017520" cy="521207"/>
           </a:xfrm>
           <a:prstGeom prst="rect">
             <a:avLst/>
@@ -36592,7 +36593,7 @@
               <a:spcAft>
                 <a:spcPts val="500"/>
               </a:spcAft>
-              <a:defRPr sz="2300" b="1">
+              <a:defRPr sz="1900" b="1">
                 <a:solidFill>
                   <a:srgbClr val="FFFFFF"/>
                 </a:solidFill>
@@ -36600,66 +36601,27 @@
               </a:defRPr>
             </a:pPr>
             <a:r>
-              <a:t>LÀNH</a:t>
-            </a:r>
-          </a:p>
-        </p:txBody>
-      </p:sp>
-      <p:sp>
-        <p:nvSpPr>
-          <p:cNvPr id="16" name="TextBox 15"/>
-          <p:cNvSpPr txBox="1"/>
-          <p:nvPr/>
-        </p:nvSpPr>
-        <p:spPr>
-          <a:xfrm>
-            <a:off x="6400800" y="2743200"/>
-            <a:ext cx="2011680" cy="457200"/>
-          </a:xfrm>
-          <a:prstGeom prst="rect">
-            <a:avLst/>
-          </a:prstGeom>
-          <a:noFill/>
-        </p:spPr>
-        <p:txBody>
-          <a:bodyPr wrap="square" lIns="9144" rIns="9144" tIns="9144" bIns="9144" anchor="t">
-            <a:spAutoFit/>
-          </a:bodyPr>
-          <a:lstStyle/>
-          <a:p>
-            <a:pPr algn="ctr">
-              <a:spcAft>
-                <a:spcPts val="500"/>
-              </a:spcAft>
-              <a:defRPr sz="2200" b="1">
-                <a:solidFill>
-                  <a:srgbClr val="FFFFFF"/>
-                </a:solidFill>
-                <a:latin typeface="Noto Sans"/>
-              </a:defRPr>
-            </a:pPr>
-            <a:r>
-              <a:t>h₃(x)</a:t>
-            </a:r>
-          </a:p>
-        </p:txBody>
-      </p:sp>
-      <p:sp>
-        <p:nvSpPr>
-          <p:cNvPr id="17" name="Oval 16"/>
+              <a:t>Ngưỡng học được</a:t>
+            </a:r>
+          </a:p>
+        </p:txBody>
+      </p:sp>
+      <p:sp>
+        <p:nvSpPr>
+          <p:cNvPr id="14" name="Rectangle 13"/>
           <p:cNvSpPr/>
           <p:nvPr/>
         </p:nvSpPr>
         <p:spPr>
           <a:xfrm>
-            <a:off x="6720840" y="3474720"/>
-            <a:ext cx="1325880" cy="1325880"/>
-          </a:xfrm>
-          <a:prstGeom prst="ellipse">
+            <a:off x="5166360" y="2423160"/>
+            <a:ext cx="3268980" cy="644652"/>
+          </a:xfrm>
+          <a:prstGeom prst="rect">
             <a:avLst/>
           </a:prstGeom>
           <a:solidFill>
-            <a:srgbClr val="087E83"/>
+            <a:srgbClr val="102537"/>
           </a:solidFill>
           <a:ln>
             <a:noFill/>
@@ -36689,14 +36651,14 @@
       </p:sp>
       <p:sp>
         <p:nvSpPr>
-          <p:cNvPr id="18" name="TextBox 17"/>
-          <p:cNvSpPr txBox="1"/>
-          <p:nvPr/>
-        </p:nvSpPr>
-        <p:spPr>
-          <a:xfrm>
-            <a:off x="6720840" y="3753154"/>
-            <a:ext cx="1325880" cy="769010"/>
+          <p:cNvPr id="15" name="TextBox 14"/>
+          <p:cNvSpPr txBox="1"/>
+          <p:nvPr/>
+        </p:nvSpPr>
+        <p:spPr>
+          <a:xfrm>
+            <a:off x="5303520" y="2532888"/>
+            <a:ext cx="3017520" cy="521207"/>
           </a:xfrm>
           <a:prstGeom prst="rect">
             <a:avLst/>
@@ -36713,7 +36675,7 @@
               <a:spcAft>
                 <a:spcPts val="500"/>
               </a:spcAft>
-              <a:defRPr sz="2300" b="1">
+              <a:defRPr sz="1900" b="1">
                 <a:solidFill>
                   <a:srgbClr val="FFFFFF"/>
                 </a:solidFill>
@@ -36721,27 +36683,27 @@
               </a:defRPr>
             </a:pPr>
             <a:r>
-              <a:t>ÁC</a:t>
-            </a:r>
-          </a:p>
-        </p:txBody>
-      </p:sp>
-      <p:sp>
-        <p:nvSpPr>
-          <p:cNvPr id="19" name="Right Arrow 18"/>
+              <a:t>So sánh x = 2,8</a:t>
+            </a:r>
+          </a:p>
+        </p:txBody>
+      </p:sp>
+      <p:sp>
+        <p:nvSpPr>
+          <p:cNvPr id="16" name="Rectangle 15"/>
           <p:cNvSpPr/>
           <p:nvPr/>
         </p:nvSpPr>
         <p:spPr>
           <a:xfrm>
-            <a:off x="8641080" y="3977639"/>
-            <a:ext cx="548640" cy="320040"/>
-          </a:xfrm>
-          <a:prstGeom prst="rightArrow">
+            <a:off x="8458200" y="2423160"/>
+            <a:ext cx="3086100" cy="644652"/>
+          </a:xfrm>
+          <a:prstGeom prst="rect">
             <a:avLst/>
           </a:prstGeom>
           <a:solidFill>
-            <a:srgbClr val="79E2CC"/>
+            <a:srgbClr val="102537"/>
           </a:solidFill>
           <a:ln>
             <a:noFill/>
@@ -36771,14 +36733,96 @@
       </p:sp>
       <p:sp>
         <p:nvSpPr>
-          <p:cNvPr id="20" name="TextBox 19"/>
-          <p:cNvSpPr txBox="1"/>
-          <p:nvPr/>
-        </p:nvSpPr>
-        <p:spPr>
-          <a:xfrm>
-            <a:off x="9555480" y="3474720"/>
-            <a:ext cx="1920240" cy="731520"/>
+          <p:cNvPr id="17" name="TextBox 16"/>
+          <p:cNvSpPr txBox="1"/>
+          <p:nvPr/>
+        </p:nvSpPr>
+        <p:spPr>
+          <a:xfrm>
+            <a:off x="8595360" y="2532888"/>
+            <a:ext cx="2834640" cy="521207"/>
+          </a:xfrm>
+          <a:prstGeom prst="rect">
+            <a:avLst/>
+          </a:prstGeom>
+          <a:noFill/>
+        </p:spPr>
+        <p:txBody>
+          <a:bodyPr wrap="square" lIns="9144" rIns="9144" tIns="9144" bIns="9144" anchor="t">
+            <a:spAutoFit/>
+          </a:bodyPr>
+          <a:lstStyle/>
+          <a:p>
+            <a:pPr algn="ctr">
+              <a:spcAft>
+                <a:spcPts val="500"/>
+              </a:spcAft>
+              <a:defRPr sz="1900" b="1">
+                <a:solidFill>
+                  <a:srgbClr val="FFFFFF"/>
+                </a:solidFill>
+                <a:latin typeface="Noto Sans"/>
+              </a:defRPr>
+            </a:pPr>
+            <a:r>
+              <a:t>Phiếu</a:t>
+            </a:r>
+          </a:p>
+        </p:txBody>
+      </p:sp>
+      <p:sp>
+        <p:nvSpPr>
+          <p:cNvPr id="18" name="Rectangle 17"/>
+          <p:cNvSpPr/>
+          <p:nvPr/>
+        </p:nvSpPr>
+        <p:spPr>
+          <a:xfrm>
+            <a:off x="594360" y="3090672"/>
+            <a:ext cx="1257300" cy="644652"/>
+          </a:xfrm>
+          <a:prstGeom prst="rect">
+            <a:avLst/>
+          </a:prstGeom>
+          <a:solidFill>
+            <a:srgbClr val="FFFFFF"/>
+          </a:solidFill>
+          <a:ln>
+            <a:noFill/>
+          </a:ln>
+        </p:spPr>
+        <p:style>
+          <a:lnRef idx="1">
+            <a:schemeClr val="accent1"/>
+          </a:lnRef>
+          <a:fillRef idx="3">
+            <a:schemeClr val="accent1"/>
+          </a:fillRef>
+          <a:effectRef idx="2">
+            <a:schemeClr val="accent1"/>
+          </a:effectRef>
+          <a:fontRef idx="minor">
+            <a:schemeClr val="lt1"/>
+          </a:fontRef>
+        </p:style>
+        <p:txBody>
+          <a:bodyPr rtlCol="0" anchor="ctr"/>
+          <a:lstStyle/>
+          <a:p>
+            <a:pPr algn="ctr"/>
+          </a:p>
+        </p:txBody>
+      </p:sp>
+      <p:sp>
+        <p:nvSpPr>
+          <p:cNvPr id="19" name="TextBox 18"/>
+          <p:cNvSpPr txBox="1"/>
+          <p:nvPr/>
+        </p:nvSpPr>
+        <p:spPr>
+          <a:xfrm>
+            <a:off x="731520" y="3200400"/>
+            <a:ext cx="1005839" cy="521207"/>
           </a:xfrm>
           <a:prstGeom prst="rect">
             <a:avLst/>
@@ -36795,16 +36839,59 @@
               <a:spcAft>
                 <a:spcPts val="500"/>
               </a:spcAft>
-              <a:defRPr sz="3700" b="1">
-                <a:solidFill>
-                  <a:srgbClr val="79E2CC"/>
-                </a:solidFill>
-                <a:latin typeface="Noto Sans"/>
-              </a:defRPr>
-            </a:pPr>
-            <a:r>
-              <a:t>2 : 1</a:t>
-            </a:r>
+              <a:defRPr sz="1900" b="0">
+                <a:solidFill>
+                  <a:srgbClr val="173246"/>
+                </a:solidFill>
+                <a:latin typeface="Noto Sans"/>
+              </a:defRPr>
+            </a:pPr>
+            <a:r>
+              <a:t>h1</a:t>
+            </a:r>
+          </a:p>
+        </p:txBody>
+      </p:sp>
+      <p:sp>
+        <p:nvSpPr>
+          <p:cNvPr id="20" name="Rectangle 19"/>
+          <p:cNvSpPr/>
+          <p:nvPr/>
+        </p:nvSpPr>
+        <p:spPr>
+          <a:xfrm>
+            <a:off x="1874519" y="3090672"/>
+            <a:ext cx="3268980" cy="644652"/>
+          </a:xfrm>
+          <a:prstGeom prst="rect">
+            <a:avLst/>
+          </a:prstGeom>
+          <a:solidFill>
+            <a:srgbClr val="FFFFFF"/>
+          </a:solidFill>
+          <a:ln>
+            <a:noFill/>
+          </a:ln>
+        </p:spPr>
+        <p:style>
+          <a:lnRef idx="1">
+            <a:schemeClr val="accent1"/>
+          </a:lnRef>
+          <a:fillRef idx="3">
+            <a:schemeClr val="accent1"/>
+          </a:fillRef>
+          <a:effectRef idx="2">
+            <a:schemeClr val="accent1"/>
+          </a:effectRef>
+          <a:fontRef idx="minor">
+            <a:schemeClr val="lt1"/>
+          </a:fontRef>
+        </p:style>
+        <p:txBody>
+          <a:bodyPr rtlCol="0" anchor="ctr"/>
+          <a:lstStyle/>
+          <a:p>
+            <a:pPr algn="ctr"/>
           </a:p>
         </p:txBody>
       </p:sp>
@@ -36816,8 +36903,254 @@
         </p:nvSpPr>
         <p:spPr>
           <a:xfrm>
-            <a:off x="9555480" y="4343400"/>
-            <a:ext cx="1920240" cy="457200"/>
+            <a:off x="2011679" y="3200400"/>
+            <a:ext cx="3017520" cy="521207"/>
+          </a:xfrm>
+          <a:prstGeom prst="rect">
+            <a:avLst/>
+          </a:prstGeom>
+          <a:noFill/>
+        </p:spPr>
+        <p:txBody>
+          <a:bodyPr wrap="square" lIns="9144" rIns="9144" tIns="9144" bIns="9144" anchor="t">
+            <a:spAutoFit/>
+          </a:bodyPr>
+          <a:lstStyle/>
+          <a:p>
+            <a:pPr algn="ctr">
+              <a:spcAft>
+                <a:spcPts val="500"/>
+              </a:spcAft>
+              <a:defRPr sz="1900" b="0">
+                <a:solidFill>
+                  <a:srgbClr val="173246"/>
+                </a:solidFill>
+                <a:latin typeface="Noto Sans"/>
+              </a:defRPr>
+            </a:pPr>
+            <a:r>
+              <a:t>2,5</a:t>
+            </a:r>
+          </a:p>
+        </p:txBody>
+      </p:sp>
+      <p:sp>
+        <p:nvSpPr>
+          <p:cNvPr id="22" name="Rectangle 21"/>
+          <p:cNvSpPr/>
+          <p:nvPr/>
+        </p:nvSpPr>
+        <p:spPr>
+          <a:xfrm>
+            <a:off x="5166360" y="3090672"/>
+            <a:ext cx="3268980" cy="644652"/>
+          </a:xfrm>
+          <a:prstGeom prst="rect">
+            <a:avLst/>
+          </a:prstGeom>
+          <a:solidFill>
+            <a:srgbClr val="FFFFFF"/>
+          </a:solidFill>
+          <a:ln>
+            <a:noFill/>
+          </a:ln>
+        </p:spPr>
+        <p:style>
+          <a:lnRef idx="1">
+            <a:schemeClr val="accent1"/>
+          </a:lnRef>
+          <a:fillRef idx="3">
+            <a:schemeClr val="accent1"/>
+          </a:fillRef>
+          <a:effectRef idx="2">
+            <a:schemeClr val="accent1"/>
+          </a:effectRef>
+          <a:fontRef idx="minor">
+            <a:schemeClr val="lt1"/>
+          </a:fontRef>
+        </p:style>
+        <p:txBody>
+          <a:bodyPr rtlCol="0" anchor="ctr"/>
+          <a:lstStyle/>
+          <a:p>
+            <a:pPr algn="ctr"/>
+          </a:p>
+        </p:txBody>
+      </p:sp>
+      <p:sp>
+        <p:nvSpPr>
+          <p:cNvPr id="23" name="TextBox 22"/>
+          <p:cNvSpPr txBox="1"/>
+          <p:nvPr/>
+        </p:nvSpPr>
+        <p:spPr>
+          <a:xfrm>
+            <a:off x="5303520" y="3200400"/>
+            <a:ext cx="3017520" cy="521207"/>
+          </a:xfrm>
+          <a:prstGeom prst="rect">
+            <a:avLst/>
+          </a:prstGeom>
+          <a:noFill/>
+        </p:spPr>
+        <p:txBody>
+          <a:bodyPr wrap="square" lIns="9144" rIns="9144" tIns="9144" bIns="9144" anchor="t">
+            <a:spAutoFit/>
+          </a:bodyPr>
+          <a:lstStyle/>
+          <a:p>
+            <a:pPr algn="ctr">
+              <a:spcAft>
+                <a:spcPts val="500"/>
+              </a:spcAft>
+              <a:defRPr sz="1900" b="0">
+                <a:solidFill>
+                  <a:srgbClr val="173246"/>
+                </a:solidFill>
+                <a:latin typeface="Noto Sans"/>
+              </a:defRPr>
+            </a:pPr>
+            <a:r>
+              <a:t>2,8 &gt; 2,5</a:t>
+            </a:r>
+          </a:p>
+        </p:txBody>
+      </p:sp>
+      <p:sp>
+        <p:nvSpPr>
+          <p:cNvPr id="24" name="Rectangle 23"/>
+          <p:cNvSpPr/>
+          <p:nvPr/>
+        </p:nvSpPr>
+        <p:spPr>
+          <a:xfrm>
+            <a:off x="8458200" y="3090672"/>
+            <a:ext cx="3086100" cy="644652"/>
+          </a:xfrm>
+          <a:prstGeom prst="rect">
+            <a:avLst/>
+          </a:prstGeom>
+          <a:solidFill>
+            <a:srgbClr val="FFFFFF"/>
+          </a:solidFill>
+          <a:ln>
+            <a:noFill/>
+          </a:ln>
+        </p:spPr>
+        <p:style>
+          <a:lnRef idx="1">
+            <a:schemeClr val="accent1"/>
+          </a:lnRef>
+          <a:fillRef idx="3">
+            <a:schemeClr val="accent1"/>
+          </a:fillRef>
+          <a:effectRef idx="2">
+            <a:schemeClr val="accent1"/>
+          </a:effectRef>
+          <a:fontRef idx="minor">
+            <a:schemeClr val="lt1"/>
+          </a:fontRef>
+        </p:style>
+        <p:txBody>
+          <a:bodyPr rtlCol="0" anchor="ctr"/>
+          <a:lstStyle/>
+          <a:p>
+            <a:pPr algn="ctr"/>
+          </a:p>
+        </p:txBody>
+      </p:sp>
+      <p:sp>
+        <p:nvSpPr>
+          <p:cNvPr id="25" name="TextBox 24"/>
+          <p:cNvSpPr txBox="1"/>
+          <p:nvPr/>
+        </p:nvSpPr>
+        <p:spPr>
+          <a:xfrm>
+            <a:off x="8595360" y="3200400"/>
+            <a:ext cx="2834640" cy="521207"/>
+          </a:xfrm>
+          <a:prstGeom prst="rect">
+            <a:avLst/>
+          </a:prstGeom>
+          <a:noFill/>
+        </p:spPr>
+        <p:txBody>
+          <a:bodyPr wrap="square" lIns="9144" rIns="9144" tIns="9144" bIns="9144" anchor="t">
+            <a:spAutoFit/>
+          </a:bodyPr>
+          <a:lstStyle/>
+          <a:p>
+            <a:pPr algn="ctr">
+              <a:spcAft>
+                <a:spcPts val="500"/>
+              </a:spcAft>
+              <a:defRPr sz="1900" b="0">
+                <a:solidFill>
+                  <a:srgbClr val="173246"/>
+                </a:solidFill>
+                <a:latin typeface="Noto Sans"/>
+              </a:defRPr>
+            </a:pPr>
+            <a:r>
+              <a:t>Ác tính (0)</a:t>
+            </a:r>
+          </a:p>
+        </p:txBody>
+      </p:sp>
+      <p:sp>
+        <p:nvSpPr>
+          <p:cNvPr id="26" name="Rectangle 25"/>
+          <p:cNvSpPr/>
+          <p:nvPr/>
+        </p:nvSpPr>
+        <p:spPr>
+          <a:xfrm>
+            <a:off x="594360" y="3758183"/>
+            <a:ext cx="1257300" cy="644652"/>
+          </a:xfrm>
+          <a:prstGeom prst="rect">
+            <a:avLst/>
+          </a:prstGeom>
+          <a:solidFill>
+            <a:srgbClr val="FFFFFF"/>
+          </a:solidFill>
+          <a:ln>
+            <a:noFill/>
+          </a:ln>
+        </p:spPr>
+        <p:style>
+          <a:lnRef idx="1">
+            <a:schemeClr val="accent1"/>
+          </a:lnRef>
+          <a:fillRef idx="3">
+            <a:schemeClr val="accent1"/>
+          </a:fillRef>
+          <a:effectRef idx="2">
+            <a:schemeClr val="accent1"/>
+          </a:effectRef>
+          <a:fontRef idx="minor">
+            <a:schemeClr val="lt1"/>
+          </a:fontRef>
+        </p:style>
+        <p:txBody>
+          <a:bodyPr rtlCol="0" anchor="ctr"/>
+          <a:lstStyle/>
+          <a:p>
+            <a:pPr algn="ctr"/>
+          </a:p>
+        </p:txBody>
+      </p:sp>
+      <p:sp>
+        <p:nvSpPr>
+          <p:cNvPr id="27" name="TextBox 26"/>
+          <p:cNvSpPr txBox="1"/>
+          <p:nvPr/>
+        </p:nvSpPr>
+        <p:spPr>
+          <a:xfrm>
+            <a:off x="731520" y="3867911"/>
+            <a:ext cx="1005839" cy="521207"/>
           </a:xfrm>
           <a:prstGeom prst="rect">
             <a:avLst/>
@@ -36834,7 +37167,665 @@
               <a:spcAft>
                 <a:spcPts val="500"/>
               </a:spcAft>
-              <a:defRPr sz="2300" b="1">
+              <a:defRPr sz="1900" b="0">
+                <a:solidFill>
+                  <a:srgbClr val="173246"/>
+                </a:solidFill>
+                <a:latin typeface="Noto Sans"/>
+              </a:defRPr>
+            </a:pPr>
+            <a:r>
+              <a:t>h2</a:t>
+            </a:r>
+          </a:p>
+        </p:txBody>
+      </p:sp>
+      <p:sp>
+        <p:nvSpPr>
+          <p:cNvPr id="28" name="Rectangle 27"/>
+          <p:cNvSpPr/>
+          <p:nvPr/>
+        </p:nvSpPr>
+        <p:spPr>
+          <a:xfrm>
+            <a:off x="1874519" y="3758183"/>
+            <a:ext cx="3268980" cy="644652"/>
+          </a:xfrm>
+          <a:prstGeom prst="rect">
+            <a:avLst/>
+          </a:prstGeom>
+          <a:solidFill>
+            <a:srgbClr val="FFFFFF"/>
+          </a:solidFill>
+          <a:ln>
+            <a:noFill/>
+          </a:ln>
+        </p:spPr>
+        <p:style>
+          <a:lnRef idx="1">
+            <a:schemeClr val="accent1"/>
+          </a:lnRef>
+          <a:fillRef idx="3">
+            <a:schemeClr val="accent1"/>
+          </a:fillRef>
+          <a:effectRef idx="2">
+            <a:schemeClr val="accent1"/>
+          </a:effectRef>
+          <a:fontRef idx="minor">
+            <a:schemeClr val="lt1"/>
+          </a:fontRef>
+        </p:style>
+        <p:txBody>
+          <a:bodyPr rtlCol="0" anchor="ctr"/>
+          <a:lstStyle/>
+          <a:p>
+            <a:pPr algn="ctr"/>
+          </a:p>
+        </p:txBody>
+      </p:sp>
+      <p:sp>
+        <p:nvSpPr>
+          <p:cNvPr id="29" name="TextBox 28"/>
+          <p:cNvSpPr txBox="1"/>
+          <p:nvPr/>
+        </p:nvSpPr>
+        <p:spPr>
+          <a:xfrm>
+            <a:off x="2011679" y="3867911"/>
+            <a:ext cx="3017520" cy="521207"/>
+          </a:xfrm>
+          <a:prstGeom prst="rect">
+            <a:avLst/>
+          </a:prstGeom>
+          <a:noFill/>
+        </p:spPr>
+        <p:txBody>
+          <a:bodyPr wrap="square" lIns="9144" rIns="9144" tIns="9144" bIns="9144" anchor="t">
+            <a:spAutoFit/>
+          </a:bodyPr>
+          <a:lstStyle/>
+          <a:p>
+            <a:pPr algn="ctr">
+              <a:spcAft>
+                <a:spcPts val="500"/>
+              </a:spcAft>
+              <a:defRPr sz="1900" b="0">
+                <a:solidFill>
+                  <a:srgbClr val="173246"/>
+                </a:solidFill>
+                <a:latin typeface="Noto Sans"/>
+              </a:defRPr>
+            </a:pPr>
+            <a:r>
+              <a:t>3</a:t>
+            </a:r>
+          </a:p>
+        </p:txBody>
+      </p:sp>
+      <p:sp>
+        <p:nvSpPr>
+          <p:cNvPr id="30" name="Rectangle 29"/>
+          <p:cNvSpPr/>
+          <p:nvPr/>
+        </p:nvSpPr>
+        <p:spPr>
+          <a:xfrm>
+            <a:off x="5166360" y="3758183"/>
+            <a:ext cx="3268980" cy="644652"/>
+          </a:xfrm>
+          <a:prstGeom prst="rect">
+            <a:avLst/>
+          </a:prstGeom>
+          <a:solidFill>
+            <a:srgbClr val="FFFFFF"/>
+          </a:solidFill>
+          <a:ln>
+            <a:noFill/>
+          </a:ln>
+        </p:spPr>
+        <p:style>
+          <a:lnRef idx="1">
+            <a:schemeClr val="accent1"/>
+          </a:lnRef>
+          <a:fillRef idx="3">
+            <a:schemeClr val="accent1"/>
+          </a:fillRef>
+          <a:effectRef idx="2">
+            <a:schemeClr val="accent1"/>
+          </a:effectRef>
+          <a:fontRef idx="minor">
+            <a:schemeClr val="lt1"/>
+          </a:fontRef>
+        </p:style>
+        <p:txBody>
+          <a:bodyPr rtlCol="0" anchor="ctr"/>
+          <a:lstStyle/>
+          <a:p>
+            <a:pPr algn="ctr"/>
+          </a:p>
+        </p:txBody>
+      </p:sp>
+      <p:sp>
+        <p:nvSpPr>
+          <p:cNvPr id="31" name="TextBox 30"/>
+          <p:cNvSpPr txBox="1"/>
+          <p:nvPr/>
+        </p:nvSpPr>
+        <p:spPr>
+          <a:xfrm>
+            <a:off x="5303520" y="3867911"/>
+            <a:ext cx="3017520" cy="521207"/>
+          </a:xfrm>
+          <a:prstGeom prst="rect">
+            <a:avLst/>
+          </a:prstGeom>
+          <a:noFill/>
+        </p:spPr>
+        <p:txBody>
+          <a:bodyPr wrap="square" lIns="9144" rIns="9144" tIns="9144" bIns="9144" anchor="t">
+            <a:spAutoFit/>
+          </a:bodyPr>
+          <a:lstStyle/>
+          <a:p>
+            <a:pPr algn="ctr">
+              <a:spcAft>
+                <a:spcPts val="500"/>
+              </a:spcAft>
+              <a:defRPr sz="1900" b="0">
+                <a:solidFill>
+                  <a:srgbClr val="173246"/>
+                </a:solidFill>
+                <a:latin typeface="Noto Sans"/>
+              </a:defRPr>
+            </a:pPr>
+            <a:r>
+              <a:t>2,8 ≤ 3</a:t>
+            </a:r>
+          </a:p>
+        </p:txBody>
+      </p:sp>
+      <p:sp>
+        <p:nvSpPr>
+          <p:cNvPr id="32" name="Rectangle 31"/>
+          <p:cNvSpPr/>
+          <p:nvPr/>
+        </p:nvSpPr>
+        <p:spPr>
+          <a:xfrm>
+            <a:off x="8458200" y="3758183"/>
+            <a:ext cx="3086100" cy="644652"/>
+          </a:xfrm>
+          <a:prstGeom prst="rect">
+            <a:avLst/>
+          </a:prstGeom>
+          <a:solidFill>
+            <a:srgbClr val="FFFFFF"/>
+          </a:solidFill>
+          <a:ln>
+            <a:noFill/>
+          </a:ln>
+        </p:spPr>
+        <p:style>
+          <a:lnRef idx="1">
+            <a:schemeClr val="accent1"/>
+          </a:lnRef>
+          <a:fillRef idx="3">
+            <a:schemeClr val="accent1"/>
+          </a:fillRef>
+          <a:effectRef idx="2">
+            <a:schemeClr val="accent1"/>
+          </a:effectRef>
+          <a:fontRef idx="minor">
+            <a:schemeClr val="lt1"/>
+          </a:fontRef>
+        </p:style>
+        <p:txBody>
+          <a:bodyPr rtlCol="0" anchor="ctr"/>
+          <a:lstStyle/>
+          <a:p>
+            <a:pPr algn="ctr"/>
+          </a:p>
+        </p:txBody>
+      </p:sp>
+      <p:sp>
+        <p:nvSpPr>
+          <p:cNvPr id="33" name="TextBox 32"/>
+          <p:cNvSpPr txBox="1"/>
+          <p:nvPr/>
+        </p:nvSpPr>
+        <p:spPr>
+          <a:xfrm>
+            <a:off x="8595360" y="3867911"/>
+            <a:ext cx="2834640" cy="521207"/>
+          </a:xfrm>
+          <a:prstGeom prst="rect">
+            <a:avLst/>
+          </a:prstGeom>
+          <a:noFill/>
+        </p:spPr>
+        <p:txBody>
+          <a:bodyPr wrap="square" lIns="9144" rIns="9144" tIns="9144" bIns="9144" anchor="t">
+            <a:spAutoFit/>
+          </a:bodyPr>
+          <a:lstStyle/>
+          <a:p>
+            <a:pPr algn="ctr">
+              <a:spcAft>
+                <a:spcPts val="500"/>
+              </a:spcAft>
+              <a:defRPr sz="1900" b="0">
+                <a:solidFill>
+                  <a:srgbClr val="173246"/>
+                </a:solidFill>
+                <a:latin typeface="Noto Sans"/>
+              </a:defRPr>
+            </a:pPr>
+            <a:r>
+              <a:t>Lành tính (1)</a:t>
+            </a:r>
+          </a:p>
+        </p:txBody>
+      </p:sp>
+      <p:sp>
+        <p:nvSpPr>
+          <p:cNvPr id="34" name="Rectangle 33"/>
+          <p:cNvSpPr/>
+          <p:nvPr/>
+        </p:nvSpPr>
+        <p:spPr>
+          <a:xfrm>
+            <a:off x="594360" y="4425696"/>
+            <a:ext cx="1257300" cy="644652"/>
+          </a:xfrm>
+          <a:prstGeom prst="rect">
+            <a:avLst/>
+          </a:prstGeom>
+          <a:solidFill>
+            <a:srgbClr val="FFFFFF"/>
+          </a:solidFill>
+          <a:ln>
+            <a:noFill/>
+          </a:ln>
+        </p:spPr>
+        <p:style>
+          <a:lnRef idx="1">
+            <a:schemeClr val="accent1"/>
+          </a:lnRef>
+          <a:fillRef idx="3">
+            <a:schemeClr val="accent1"/>
+          </a:fillRef>
+          <a:effectRef idx="2">
+            <a:schemeClr val="accent1"/>
+          </a:effectRef>
+          <a:fontRef idx="minor">
+            <a:schemeClr val="lt1"/>
+          </a:fontRef>
+        </p:style>
+        <p:txBody>
+          <a:bodyPr rtlCol="0" anchor="ctr"/>
+          <a:lstStyle/>
+          <a:p>
+            <a:pPr algn="ctr"/>
+          </a:p>
+        </p:txBody>
+      </p:sp>
+      <p:sp>
+        <p:nvSpPr>
+          <p:cNvPr id="35" name="TextBox 34"/>
+          <p:cNvSpPr txBox="1"/>
+          <p:nvPr/>
+        </p:nvSpPr>
+        <p:spPr>
+          <a:xfrm>
+            <a:off x="731520" y="4535424"/>
+            <a:ext cx="1005839" cy="521207"/>
+          </a:xfrm>
+          <a:prstGeom prst="rect">
+            <a:avLst/>
+          </a:prstGeom>
+          <a:noFill/>
+        </p:spPr>
+        <p:txBody>
+          <a:bodyPr wrap="square" lIns="9144" rIns="9144" tIns="9144" bIns="9144" anchor="t">
+            <a:spAutoFit/>
+          </a:bodyPr>
+          <a:lstStyle/>
+          <a:p>
+            <a:pPr algn="l">
+              <a:spcAft>
+                <a:spcPts val="500"/>
+              </a:spcAft>
+              <a:defRPr sz="1900" b="0">
+                <a:solidFill>
+                  <a:srgbClr val="173246"/>
+                </a:solidFill>
+                <a:latin typeface="Noto Sans"/>
+              </a:defRPr>
+            </a:pPr>
+            <a:r>
+              <a:t>h3</a:t>
+            </a:r>
+          </a:p>
+        </p:txBody>
+      </p:sp>
+      <p:sp>
+        <p:nvSpPr>
+          <p:cNvPr id="36" name="Rectangle 35"/>
+          <p:cNvSpPr/>
+          <p:nvPr/>
+        </p:nvSpPr>
+        <p:spPr>
+          <a:xfrm>
+            <a:off x="1874519" y="4425696"/>
+            <a:ext cx="3268980" cy="644652"/>
+          </a:xfrm>
+          <a:prstGeom prst="rect">
+            <a:avLst/>
+          </a:prstGeom>
+          <a:solidFill>
+            <a:srgbClr val="FFFFFF"/>
+          </a:solidFill>
+          <a:ln>
+            <a:noFill/>
+          </a:ln>
+        </p:spPr>
+        <p:style>
+          <a:lnRef idx="1">
+            <a:schemeClr val="accent1"/>
+          </a:lnRef>
+          <a:fillRef idx="3">
+            <a:schemeClr val="accent1"/>
+          </a:fillRef>
+          <a:effectRef idx="2">
+            <a:schemeClr val="accent1"/>
+          </a:effectRef>
+          <a:fontRef idx="minor">
+            <a:schemeClr val="lt1"/>
+          </a:fontRef>
+        </p:style>
+        <p:txBody>
+          <a:bodyPr rtlCol="0" anchor="ctr"/>
+          <a:lstStyle/>
+          <a:p>
+            <a:pPr algn="ctr"/>
+          </a:p>
+        </p:txBody>
+      </p:sp>
+      <p:sp>
+        <p:nvSpPr>
+          <p:cNvPr id="37" name="TextBox 36"/>
+          <p:cNvSpPr txBox="1"/>
+          <p:nvPr/>
+        </p:nvSpPr>
+        <p:spPr>
+          <a:xfrm>
+            <a:off x="2011679" y="4535424"/>
+            <a:ext cx="3017520" cy="521207"/>
+          </a:xfrm>
+          <a:prstGeom prst="rect">
+            <a:avLst/>
+          </a:prstGeom>
+          <a:noFill/>
+        </p:spPr>
+        <p:txBody>
+          <a:bodyPr wrap="square" lIns="9144" rIns="9144" tIns="9144" bIns="9144" anchor="t">
+            <a:spAutoFit/>
+          </a:bodyPr>
+          <a:lstStyle/>
+          <a:p>
+            <a:pPr algn="ctr">
+              <a:spcAft>
+                <a:spcPts val="500"/>
+              </a:spcAft>
+              <a:defRPr sz="1900" b="0">
+                <a:solidFill>
+                  <a:srgbClr val="173246"/>
+                </a:solidFill>
+                <a:latin typeface="Noto Sans"/>
+              </a:defRPr>
+            </a:pPr>
+            <a:r>
+              <a:t>2,5</a:t>
+            </a:r>
+          </a:p>
+        </p:txBody>
+      </p:sp>
+      <p:sp>
+        <p:nvSpPr>
+          <p:cNvPr id="38" name="Rectangle 37"/>
+          <p:cNvSpPr/>
+          <p:nvPr/>
+        </p:nvSpPr>
+        <p:spPr>
+          <a:xfrm>
+            <a:off x="5166360" y="4425696"/>
+            <a:ext cx="3268980" cy="644652"/>
+          </a:xfrm>
+          <a:prstGeom prst="rect">
+            <a:avLst/>
+          </a:prstGeom>
+          <a:solidFill>
+            <a:srgbClr val="FFFFFF"/>
+          </a:solidFill>
+          <a:ln>
+            <a:noFill/>
+          </a:ln>
+        </p:spPr>
+        <p:style>
+          <a:lnRef idx="1">
+            <a:schemeClr val="accent1"/>
+          </a:lnRef>
+          <a:fillRef idx="3">
+            <a:schemeClr val="accent1"/>
+          </a:fillRef>
+          <a:effectRef idx="2">
+            <a:schemeClr val="accent1"/>
+          </a:effectRef>
+          <a:fontRef idx="minor">
+            <a:schemeClr val="lt1"/>
+          </a:fontRef>
+        </p:style>
+        <p:txBody>
+          <a:bodyPr rtlCol="0" anchor="ctr"/>
+          <a:lstStyle/>
+          <a:p>
+            <a:pPr algn="ctr"/>
+          </a:p>
+        </p:txBody>
+      </p:sp>
+      <p:sp>
+        <p:nvSpPr>
+          <p:cNvPr id="39" name="TextBox 38"/>
+          <p:cNvSpPr txBox="1"/>
+          <p:nvPr/>
+        </p:nvSpPr>
+        <p:spPr>
+          <a:xfrm>
+            <a:off x="5303520" y="4535424"/>
+            <a:ext cx="3017520" cy="521207"/>
+          </a:xfrm>
+          <a:prstGeom prst="rect">
+            <a:avLst/>
+          </a:prstGeom>
+          <a:noFill/>
+        </p:spPr>
+        <p:txBody>
+          <a:bodyPr wrap="square" lIns="9144" rIns="9144" tIns="9144" bIns="9144" anchor="t">
+            <a:spAutoFit/>
+          </a:bodyPr>
+          <a:lstStyle/>
+          <a:p>
+            <a:pPr algn="ctr">
+              <a:spcAft>
+                <a:spcPts val="500"/>
+              </a:spcAft>
+              <a:defRPr sz="1900" b="0">
+                <a:solidFill>
+                  <a:srgbClr val="173246"/>
+                </a:solidFill>
+                <a:latin typeface="Noto Sans"/>
+              </a:defRPr>
+            </a:pPr>
+            <a:r>
+              <a:t>2,8 &gt; 2,5</a:t>
+            </a:r>
+          </a:p>
+        </p:txBody>
+      </p:sp>
+      <p:sp>
+        <p:nvSpPr>
+          <p:cNvPr id="40" name="Rectangle 39"/>
+          <p:cNvSpPr/>
+          <p:nvPr/>
+        </p:nvSpPr>
+        <p:spPr>
+          <a:xfrm>
+            <a:off x="8458200" y="4425696"/>
+            <a:ext cx="3086100" cy="644652"/>
+          </a:xfrm>
+          <a:prstGeom prst="rect">
+            <a:avLst/>
+          </a:prstGeom>
+          <a:solidFill>
+            <a:srgbClr val="FFFFFF"/>
+          </a:solidFill>
+          <a:ln>
+            <a:noFill/>
+          </a:ln>
+        </p:spPr>
+        <p:style>
+          <a:lnRef idx="1">
+            <a:schemeClr val="accent1"/>
+          </a:lnRef>
+          <a:fillRef idx="3">
+            <a:schemeClr val="accent1"/>
+          </a:fillRef>
+          <a:effectRef idx="2">
+            <a:schemeClr val="accent1"/>
+          </a:effectRef>
+          <a:fontRef idx="minor">
+            <a:schemeClr val="lt1"/>
+          </a:fontRef>
+        </p:style>
+        <p:txBody>
+          <a:bodyPr rtlCol="0" anchor="ctr"/>
+          <a:lstStyle/>
+          <a:p>
+            <a:pPr algn="ctr"/>
+          </a:p>
+        </p:txBody>
+      </p:sp>
+      <p:sp>
+        <p:nvSpPr>
+          <p:cNvPr id="41" name="TextBox 40"/>
+          <p:cNvSpPr txBox="1"/>
+          <p:nvPr/>
+        </p:nvSpPr>
+        <p:spPr>
+          <a:xfrm>
+            <a:off x="8595360" y="4535424"/>
+            <a:ext cx="2834640" cy="521207"/>
+          </a:xfrm>
+          <a:prstGeom prst="rect">
+            <a:avLst/>
+          </a:prstGeom>
+          <a:noFill/>
+        </p:spPr>
+        <p:txBody>
+          <a:bodyPr wrap="square" lIns="9144" rIns="9144" tIns="9144" bIns="9144" anchor="t">
+            <a:spAutoFit/>
+          </a:bodyPr>
+          <a:lstStyle/>
+          <a:p>
+            <a:pPr algn="ctr">
+              <a:spcAft>
+                <a:spcPts val="500"/>
+              </a:spcAft>
+              <a:defRPr sz="1900" b="0">
+                <a:solidFill>
+                  <a:srgbClr val="173246"/>
+                </a:solidFill>
+                <a:latin typeface="Noto Sans"/>
+              </a:defRPr>
+            </a:pPr>
+            <a:r>
+              <a:t>Ác tính (0)</a:t>
+            </a:r>
+          </a:p>
+        </p:txBody>
+      </p:sp>
+      <p:sp>
+        <p:nvSpPr>
+          <p:cNvPr id="42" name="Rounded Rectangle 41"/>
+          <p:cNvSpPr/>
+          <p:nvPr/>
+        </p:nvSpPr>
+        <p:spPr>
+          <a:xfrm>
+            <a:off x="594360" y="5349240"/>
+            <a:ext cx="10972800" cy="594360"/>
+          </a:xfrm>
+          <a:prstGeom prst="roundRect">
+            <a:avLst>
+              <a:gd name="adj" fmla="val 12000"/>
+            </a:avLst>
+          </a:prstGeom>
+          <a:solidFill>
+            <a:srgbClr val="102537"/>
+          </a:solidFill>
+          <a:ln>
+            <a:noFill/>
+          </a:ln>
+        </p:spPr>
+        <p:style>
+          <a:lnRef idx="1">
+            <a:schemeClr val="accent1"/>
+          </a:lnRef>
+          <a:fillRef idx="3">
+            <a:schemeClr val="accent1"/>
+          </a:fillRef>
+          <a:effectRef idx="2">
+            <a:schemeClr val="accent1"/>
+          </a:effectRef>
+          <a:fontRef idx="minor">
+            <a:schemeClr val="lt1"/>
+          </a:fontRef>
+        </p:style>
+        <p:txBody>
+          <a:bodyPr rtlCol="0" anchor="ctr"/>
+          <a:lstStyle/>
+          <a:p>
+            <a:pPr algn="ctr"/>
+          </a:p>
+        </p:txBody>
+      </p:sp>
+      <p:sp>
+        <p:nvSpPr>
+          <p:cNvPr id="43" name="TextBox 42"/>
+          <p:cNvSpPr txBox="1"/>
+          <p:nvPr/>
+        </p:nvSpPr>
+        <p:spPr>
+          <a:xfrm>
+            <a:off x="822960" y="5486400"/>
+            <a:ext cx="10515600" cy="365760"/>
+          </a:xfrm>
+          <a:prstGeom prst="rect">
+            <a:avLst/>
+          </a:prstGeom>
+          <a:noFill/>
+        </p:spPr>
+        <p:txBody>
+          <a:bodyPr wrap="square" lIns="9144" rIns="9144" tIns="9144" bIns="9144" anchor="t">
+            <a:spAutoFit/>
+          </a:bodyPr>
+          <a:lstStyle/>
+          <a:p>
+            <a:pPr algn="ctr">
+              <a:spcAft>
+                <a:spcPts val="500"/>
+              </a:spcAft>
+              <a:defRPr sz="2200" b="1">
                 <a:solidFill>
                   <a:srgbClr val="FFFFFF"/>
                 </a:solidFill>
@@ -36842,46 +37833,7 @@
               </a:defRPr>
             </a:pPr>
             <a:r>
-              <a:t>→ Ác tính</a:t>
-            </a:r>
-          </a:p>
-        </p:txBody>
-      </p:sp>
-      <p:sp>
-        <p:nvSpPr>
-          <p:cNvPr id="22" name="TextBox 21"/>
-          <p:cNvSpPr txBox="1"/>
-          <p:nvPr/>
-        </p:nvSpPr>
-        <p:spPr>
-          <a:xfrm>
-            <a:off x="685800" y="5623560"/>
-            <a:ext cx="10881360" cy="411480"/>
-          </a:xfrm>
-          <a:prstGeom prst="rect">
-            <a:avLst/>
-          </a:prstGeom>
-          <a:noFill/>
-        </p:spPr>
-        <p:txBody>
-          <a:bodyPr wrap="square" lIns="9144" rIns="9144" tIns="9144" bIns="9144" anchor="t">
-            <a:spAutoFit/>
-          </a:bodyPr>
-          <a:lstStyle/>
-          <a:p>
-            <a:pPr algn="l">
-              <a:spcAft>
-                <a:spcPts val="500"/>
-              </a:spcAft>
-              <a:defRPr sz="1800" b="0">
-                <a:solidFill>
-                  <a:srgbClr val="C9D8DF"/>
-                </a:solidFill>
-                <a:latin typeface="Noto Sans"/>
-              </a:defRPr>
-            </a:pPr>
-            <a:r>
-              <a:t>Mã hóa: ác tính = 0, lành tính = 1.  51 cây tránh hòa phiếu ở bài toán hai lớp.</a:t>
+              <a:t>2 phiếu ác : 1 phiếu lành  →  chọn ác tính (0)</a:t>
             </a:r>
           </a:p>
         </p:txBody>

</xml_diff>